<commit_message>
Actualización automática en Raíces Vivas – 2026-04-21 22:26:17 Host: Cambios: 3 archivos modificados — M 06-Entregables/Presentaciones/Raices_Vivas_Entrega_Final_Presentacion.pptx, A 06-Entregables/Presentaciones/Raices_Vivas_Entrega_Final_Presentacion.pptx.bak 08-Recursos/scripts/enrich_presentation.py
Affected files:
06-Entregables/Presentaciones/Raices_Vivas_Entrega_Final_Presentacion.pptx
06-Entregables/Presentaciones/Raices_Vivas_Entrega_Final_Presentacion.pptx.bak
08-Recursos/scripts/enrich_presentation.py
</commit_message>
<xml_diff>
--- a/06-Entregables/Presentaciones/Raices_Vivas_Entrega_Final_Presentacion.pptx
+++ b/06-Entregables/Presentaciones/Raices_Vivas_Entrega_Final_Presentacion.pptx
@@ -12,10 +12,17 @@
     <p:sldId id="260" r:id="rId6"/>
     <p:sldId id="261" r:id="rId7"/>
     <p:sldId id="262" r:id="rId8"/>
+    <p:sldId id="270" r:id="rId21"/>
+    <p:sldId id="271" r:id="rId22"/>
     <p:sldId id="263" r:id="rId9"/>
+    <p:sldId id="272" r:id="rId23"/>
+    <p:sldId id="273" r:id="rId24"/>
+    <p:sldId id="274" r:id="rId25"/>
     <p:sldId id="264" r:id="rId10"/>
     <p:sldId id="265" r:id="rId11"/>
     <p:sldId id="266" r:id="rId12"/>
+    <p:sldId id="275" r:id="rId26"/>
+    <p:sldId id="276" r:id="rId27"/>
     <p:sldId id="267" r:id="rId13"/>
     <p:sldId id="268" r:id="rId14"/>
     <p:sldId id="269" r:id="rId15"/>
@@ -12424,6 +12431,2321 @@
 </p:sld>
 </file>
 
+<file path=ppt/slides/slide15.xml><?xml version="1.0" encoding="utf-8"?>
+<p:sld xmlns:a="http://schemas.openxmlformats.org/drawingml/2006/main" xmlns:p="http://schemas.openxmlformats.org/presentationml/2006/main" xmlns:r="http://schemas.openxmlformats.org/officeDocument/2006/relationships">
+  <p:cSld>
+    <p:spTree>
+      <p:nvGrpSpPr>
+        <p:cNvPr id="1" name=""/>
+        <p:cNvGrpSpPr/>
+        <p:nvPr/>
+      </p:nvGrpSpPr>
+      <p:grpSpPr/>
+      <p:sp>
+        <p:nvSpPr>
+          <p:cNvPr id="2" name="Rectangle 1"/>
+          <p:cNvSpPr/>
+          <p:nvPr/>
+        </p:nvSpPr>
+        <p:spPr>
+          <a:xfrm>
+            <a:off x="0" y="0"/>
+            <a:ext cx="12191695" cy="6858000"/>
+          </a:xfrm>
+          <a:prstGeom prst="rect">
+            <a:avLst/>
+          </a:prstGeom>
+          <a:solidFill>
+            <a:srgbClr val="F5EDE0"/>
+          </a:solidFill>
+          <a:ln>
+            <a:noFill/>
+          </a:ln>
+          <a:effectLst/>
+        </p:spPr>
+        <p:style>
+          <a:lnRef idx="1">
+            <a:schemeClr val="accent1"/>
+          </a:lnRef>
+          <a:fillRef idx="3">
+            <a:schemeClr val="accent1"/>
+          </a:fillRef>
+          <a:effectRef idx="2">
+            <a:schemeClr val="accent1"/>
+          </a:effectRef>
+          <a:fontRef idx="minor">
+            <a:schemeClr val="lt1"/>
+          </a:fontRef>
+        </p:style>
+        <p:txBody>
+          <a:bodyPr rtlCol="0" anchor="ctr"/>
+          <a:lstStyle/>
+          <a:p>
+            <a:pPr algn="ctr"/>
+          </a:p>
+        </p:txBody>
+      </p:sp>
+      <p:sp>
+        <p:nvSpPr>
+          <p:cNvPr id="3" name="Rectangle 2"/>
+          <p:cNvSpPr/>
+          <p:nvPr/>
+        </p:nvSpPr>
+        <p:spPr>
+          <a:xfrm>
+            <a:off x="0" y="0"/>
+            <a:ext cx="320040" cy="6858000"/>
+          </a:xfrm>
+          <a:prstGeom prst="rect">
+            <a:avLst/>
+          </a:prstGeom>
+          <a:solidFill>
+            <a:srgbClr val="133A32"/>
+          </a:solidFill>
+          <a:ln>
+            <a:noFill/>
+          </a:ln>
+          <a:effectLst/>
+        </p:spPr>
+        <p:style>
+          <a:lnRef idx="1">
+            <a:schemeClr val="accent1"/>
+          </a:lnRef>
+          <a:fillRef idx="3">
+            <a:schemeClr val="accent1"/>
+          </a:fillRef>
+          <a:effectRef idx="2">
+            <a:schemeClr val="accent1"/>
+          </a:effectRef>
+          <a:fontRef idx="minor">
+            <a:schemeClr val="lt1"/>
+          </a:fontRef>
+        </p:style>
+        <p:txBody>
+          <a:bodyPr rtlCol="0" anchor="ctr"/>
+          <a:lstStyle/>
+          <a:p>
+            <a:pPr algn="ctr"/>
+          </a:p>
+        </p:txBody>
+      </p:sp>
+      <p:sp>
+        <p:nvSpPr>
+          <p:cNvPr id="4" name="Rectangle 3"/>
+          <p:cNvSpPr/>
+          <p:nvPr/>
+        </p:nvSpPr>
+        <p:spPr>
+          <a:xfrm>
+            <a:off x="320040" y="0"/>
+            <a:ext cx="11871655" cy="502920"/>
+          </a:xfrm>
+          <a:prstGeom prst="rect">
+            <a:avLst/>
+          </a:prstGeom>
+          <a:solidFill>
+            <a:srgbClr val="E9DEC9"/>
+          </a:solidFill>
+          <a:ln>
+            <a:noFill/>
+          </a:ln>
+          <a:effectLst/>
+        </p:spPr>
+        <p:style>
+          <a:lnRef idx="1">
+            <a:schemeClr val="accent1"/>
+          </a:lnRef>
+          <a:fillRef idx="3">
+            <a:schemeClr val="accent1"/>
+          </a:fillRef>
+          <a:effectRef idx="2">
+            <a:schemeClr val="accent1"/>
+          </a:effectRef>
+          <a:fontRef idx="minor">
+            <a:schemeClr val="lt1"/>
+          </a:fontRef>
+        </p:style>
+        <p:txBody>
+          <a:bodyPr rtlCol="0" anchor="ctr"/>
+          <a:lstStyle/>
+          <a:p>
+            <a:pPr algn="ctr"/>
+          </a:p>
+        </p:txBody>
+      </p:sp>
+      <p:sp>
+        <p:nvSpPr>
+          <p:cNvPr id="5" name="TextBox 4"/>
+          <p:cNvSpPr txBox="1"/>
+          <p:nvPr/>
+        </p:nvSpPr>
+        <p:spPr>
+          <a:xfrm>
+            <a:off x="731520" y="91440"/>
+            <a:ext cx="8229600" cy="320040"/>
+          </a:xfrm>
+          <a:prstGeom prst="rect">
+            <a:avLst/>
+          </a:prstGeom>
+          <a:noFill/>
+        </p:spPr>
+        <p:txBody>
+          <a:bodyPr wrap="square" lIns="0" rIns="0" tIns="0" bIns="0" anchor="ctr">
+            <a:spAutoFit/>
+          </a:bodyPr>
+          <a:lstStyle/>
+          <a:p>
+            <a:pPr algn="l"/>
+            <a:r>
+              <a:rPr sz="1100" b="1">
+                <a:solidFill>
+                  <a:srgbClr val="B85C38"/>
+                </a:solidFill>
+                <a:latin typeface="Calibri"/>
+              </a:rPr>
+              <a:t>ANEXO TÉCNICO · A.1</a:t>
+            </a:r>
+          </a:p>
+        </p:txBody>
+      </p:sp>
+      <p:sp>
+        <p:nvSpPr>
+          <p:cNvPr id="6" name="TextBox 5"/>
+          <p:cNvSpPr txBox="1"/>
+          <p:nvPr/>
+        </p:nvSpPr>
+        <p:spPr>
+          <a:xfrm>
+            <a:off x="10698480" y="91440"/>
+            <a:ext cx="1188720" cy="320040"/>
+          </a:xfrm>
+          <a:prstGeom prst="rect">
+            <a:avLst/>
+          </a:prstGeom>
+          <a:noFill/>
+        </p:spPr>
+        <p:txBody>
+          <a:bodyPr wrap="square" lIns="0" rIns="0" tIns="0" bIns="0" anchor="ctr">
+            <a:spAutoFit/>
+          </a:bodyPr>
+          <a:lstStyle/>
+          <a:p>
+            <a:pPr algn="r"/>
+            <a:r>
+              <a:rPr sz="900" b="0">
+                <a:solidFill>
+                  <a:srgbClr val="555555"/>
+                </a:solidFill>
+                <a:latin typeface="Calibri"/>
+              </a:rPr>
+              <a:t>Raíces Vivas · Entrega Final · CENFOTEC</a:t>
+            </a:r>
+          </a:p>
+        </p:txBody>
+      </p:sp>
+      <p:sp>
+        <p:nvSpPr>
+          <p:cNvPr id="7" name="TextBox 6"/>
+          <p:cNvSpPr txBox="1"/>
+          <p:nvPr/>
+        </p:nvSpPr>
+        <p:spPr>
+          <a:xfrm>
+            <a:off x="731520" y="640080"/>
+            <a:ext cx="10607040" cy="685800"/>
+          </a:xfrm>
+          <a:prstGeom prst="rect">
+            <a:avLst/>
+          </a:prstGeom>
+          <a:noFill/>
+        </p:spPr>
+        <p:txBody>
+          <a:bodyPr wrap="square" lIns="0" rIns="0" tIns="0" bIns="0" anchor="t">
+            <a:spAutoFit/>
+          </a:bodyPr>
+          <a:lstStyle/>
+          <a:p>
+            <a:pPr algn="l"/>
+            <a:r>
+              <a:rPr sz="3000" b="1">
+                <a:solidFill>
+                  <a:srgbClr val="133A32"/>
+                </a:solidFill>
+                <a:latin typeface="Calibri"/>
+              </a:rPr>
+              <a:t>DFD Nivel 0 — Diagrama de contexto</a:t>
+            </a:r>
+          </a:p>
+        </p:txBody>
+      </p:sp>
+      <p:sp>
+        <p:nvSpPr>
+          <p:cNvPr id="8" name="TextBox 7"/>
+          <p:cNvSpPr txBox="1"/>
+          <p:nvPr/>
+        </p:nvSpPr>
+        <p:spPr>
+          <a:xfrm>
+            <a:off x="731520" y="1325880"/>
+            <a:ext cx="10607040" cy="320040"/>
+          </a:xfrm>
+          <a:prstGeom prst="rect">
+            <a:avLst/>
+          </a:prstGeom>
+          <a:noFill/>
+        </p:spPr>
+        <p:txBody>
+          <a:bodyPr wrap="square" lIns="0" rIns="0" tIns="0" bIns="0" anchor="t">
+            <a:spAutoFit/>
+          </a:bodyPr>
+          <a:lstStyle/>
+          <a:p>
+            <a:pPr algn="l"/>
+            <a:r>
+              <a:rPr sz="1400" b="0">
+                <a:solidFill>
+                  <a:srgbClr val="4E6E66"/>
+                </a:solidFill>
+                <a:latin typeface="Calibri"/>
+              </a:rPr>
+              <a:t>Notación DeMarco–Yourdon</a:t>
+            </a:r>
+          </a:p>
+        </p:txBody>
+      </p:sp>
+      <p:sp>
+        <p:nvSpPr>
+          <p:cNvPr id="9" name="Rectangle 8"/>
+          <p:cNvSpPr/>
+          <p:nvPr/>
+        </p:nvSpPr>
+        <p:spPr>
+          <a:xfrm>
+            <a:off x="685800" y="1828800"/>
+            <a:ext cx="10789920" cy="4023360"/>
+          </a:xfrm>
+          <a:prstGeom prst="rect">
+            <a:avLst/>
+          </a:prstGeom>
+          <a:solidFill>
+            <a:srgbClr val="FFFFFF"/>
+          </a:solidFill>
+          <a:ln w="9525">
+            <a:solidFill>
+              <a:srgbClr val="E9DEC9"/>
+            </a:solidFill>
+          </a:ln>
+          <a:effectLst/>
+        </p:spPr>
+        <p:style>
+          <a:lnRef idx="1">
+            <a:schemeClr val="accent1"/>
+          </a:lnRef>
+          <a:fillRef idx="3">
+            <a:schemeClr val="accent1"/>
+          </a:fillRef>
+          <a:effectRef idx="2">
+            <a:schemeClr val="accent1"/>
+          </a:effectRef>
+          <a:fontRef idx="minor">
+            <a:schemeClr val="lt1"/>
+          </a:fontRef>
+        </p:style>
+        <p:txBody>
+          <a:bodyPr rtlCol="0" anchor="ctr"/>
+          <a:lstStyle/>
+          <a:p>
+            <a:pPr algn="ctr"/>
+          </a:p>
+        </p:txBody>
+      </p:sp>
+      <p:pic>
+        <p:nvPicPr>
+          <p:cNvPr id="10" name="Picture 9" descr="diagram_dfd_nivel0.png"/>
+          <p:cNvPicPr>
+            <a:picLocks noChangeAspect="1"/>
+          </p:cNvPicPr>
+          <p:nvPr/>
+        </p:nvPicPr>
+        <p:blipFill>
+          <a:blip r:embed="rId2"/>
+          <a:stretch>
+            <a:fillRect/>
+          </a:stretch>
+        </p:blipFill>
+        <p:spPr>
+          <a:xfrm>
+            <a:off x="3249717" y="1929384"/>
+            <a:ext cx="5662084" cy="3822191"/>
+          </a:xfrm>
+          <a:prstGeom prst="rect">
+            <a:avLst/>
+          </a:prstGeom>
+        </p:spPr>
+      </p:pic>
+      <p:sp>
+        <p:nvSpPr>
+          <p:cNvPr id="11" name="Rectangle 10"/>
+          <p:cNvSpPr/>
+          <p:nvPr/>
+        </p:nvSpPr>
+        <p:spPr>
+          <a:xfrm>
+            <a:off x="320040" y="5989320"/>
+            <a:ext cx="11871655" cy="685800"/>
+          </a:xfrm>
+          <a:prstGeom prst="rect">
+            <a:avLst/>
+          </a:prstGeom>
+          <a:solidFill>
+            <a:srgbClr val="133A32"/>
+          </a:solidFill>
+          <a:ln>
+            <a:noFill/>
+          </a:ln>
+          <a:effectLst/>
+        </p:spPr>
+        <p:style>
+          <a:lnRef idx="1">
+            <a:schemeClr val="accent1"/>
+          </a:lnRef>
+          <a:fillRef idx="3">
+            <a:schemeClr val="accent1"/>
+          </a:fillRef>
+          <a:effectRef idx="2">
+            <a:schemeClr val="accent1"/>
+          </a:effectRef>
+          <a:fontRef idx="minor">
+            <a:schemeClr val="lt1"/>
+          </a:fontRef>
+        </p:style>
+        <p:txBody>
+          <a:bodyPr rtlCol="0" anchor="ctr"/>
+          <a:lstStyle/>
+          <a:p>
+            <a:pPr algn="ctr"/>
+          </a:p>
+        </p:txBody>
+      </p:sp>
+      <p:sp>
+        <p:nvSpPr>
+          <p:cNvPr id="12" name="TextBox 11"/>
+          <p:cNvSpPr txBox="1"/>
+          <p:nvPr/>
+        </p:nvSpPr>
+        <p:spPr>
+          <a:xfrm>
+            <a:off x="731520" y="6035040"/>
+            <a:ext cx="10607040" cy="594360"/>
+          </a:xfrm>
+          <a:prstGeom prst="rect">
+            <a:avLst/>
+          </a:prstGeom>
+          <a:noFill/>
+        </p:spPr>
+        <p:txBody>
+          <a:bodyPr wrap="square" lIns="0" rIns="0" tIns="0" bIns="0" anchor="ctr">
+            <a:spAutoFit/>
+          </a:bodyPr>
+          <a:lstStyle/>
+          <a:p>
+            <a:pPr algn="l"/>
+            <a:r>
+              <a:rPr sz="1100" b="0">
+                <a:solidFill>
+                  <a:srgbClr val="F5EDE0"/>
+                </a:solidFill>
+                <a:latin typeface="Calibri"/>
+              </a:rPr>
+              <a:t>El sistema Raíces Vivas modelado como proceso único rodeado de sus entidades externas (6 actores humanos + 3 sistemas: MEP, CCSS/EDUS, ODS/UNESCO). Cada arista es un flujo de datos etiquetado.</a:t>
+            </a:r>
+          </a:p>
+        </p:txBody>
+      </p:sp>
+      <p:pic>
+        <p:nvPicPr>
+          <p:cNvPr id="13" name="Picture 12" descr="logo-cenfotec-200x200.png"/>
+          <p:cNvPicPr>
+            <a:picLocks noChangeAspect="1"/>
+          </p:cNvPicPr>
+          <p:nvPr/>
+        </p:nvPicPr>
+        <p:blipFill>
+          <a:blip r:embed="rId3"/>
+          <a:stretch>
+            <a:fillRect/>
+          </a:stretch>
+        </p:blipFill>
+        <p:spPr>
+          <a:xfrm>
+            <a:off x="11430000" y="6172200"/>
+            <a:ext cx="411480" cy="411480"/>
+          </a:xfrm>
+          <a:prstGeom prst="rect">
+            <a:avLst/>
+          </a:prstGeom>
+        </p:spPr>
+      </p:pic>
+    </p:spTree>
+  </p:cSld>
+  <p:clrMapOvr>
+    <a:masterClrMapping/>
+  </p:clrMapOvr>
+</p:sld>
+</file>
+
+<file path=ppt/slides/slide16.xml><?xml version="1.0" encoding="utf-8"?>
+<p:sld xmlns:a="http://schemas.openxmlformats.org/drawingml/2006/main" xmlns:p="http://schemas.openxmlformats.org/presentationml/2006/main" xmlns:r="http://schemas.openxmlformats.org/officeDocument/2006/relationships">
+  <p:cSld>
+    <p:spTree>
+      <p:nvGrpSpPr>
+        <p:cNvPr id="1" name=""/>
+        <p:cNvGrpSpPr/>
+        <p:nvPr/>
+      </p:nvGrpSpPr>
+      <p:grpSpPr/>
+      <p:sp>
+        <p:nvSpPr>
+          <p:cNvPr id="2" name="Rectangle 1"/>
+          <p:cNvSpPr/>
+          <p:nvPr/>
+        </p:nvSpPr>
+        <p:spPr>
+          <a:xfrm>
+            <a:off x="0" y="0"/>
+            <a:ext cx="12191695" cy="6858000"/>
+          </a:xfrm>
+          <a:prstGeom prst="rect">
+            <a:avLst/>
+          </a:prstGeom>
+          <a:solidFill>
+            <a:srgbClr val="F5EDE0"/>
+          </a:solidFill>
+          <a:ln>
+            <a:noFill/>
+          </a:ln>
+          <a:effectLst/>
+        </p:spPr>
+        <p:style>
+          <a:lnRef idx="1">
+            <a:schemeClr val="accent1"/>
+          </a:lnRef>
+          <a:fillRef idx="3">
+            <a:schemeClr val="accent1"/>
+          </a:fillRef>
+          <a:effectRef idx="2">
+            <a:schemeClr val="accent1"/>
+          </a:effectRef>
+          <a:fontRef idx="minor">
+            <a:schemeClr val="lt1"/>
+          </a:fontRef>
+        </p:style>
+        <p:txBody>
+          <a:bodyPr rtlCol="0" anchor="ctr"/>
+          <a:lstStyle/>
+          <a:p>
+            <a:pPr algn="ctr"/>
+          </a:p>
+        </p:txBody>
+      </p:sp>
+      <p:sp>
+        <p:nvSpPr>
+          <p:cNvPr id="3" name="Rectangle 2"/>
+          <p:cNvSpPr/>
+          <p:nvPr/>
+        </p:nvSpPr>
+        <p:spPr>
+          <a:xfrm>
+            <a:off x="0" y="0"/>
+            <a:ext cx="320040" cy="6858000"/>
+          </a:xfrm>
+          <a:prstGeom prst="rect">
+            <a:avLst/>
+          </a:prstGeom>
+          <a:solidFill>
+            <a:srgbClr val="133A32"/>
+          </a:solidFill>
+          <a:ln>
+            <a:noFill/>
+          </a:ln>
+          <a:effectLst/>
+        </p:spPr>
+        <p:style>
+          <a:lnRef idx="1">
+            <a:schemeClr val="accent1"/>
+          </a:lnRef>
+          <a:fillRef idx="3">
+            <a:schemeClr val="accent1"/>
+          </a:fillRef>
+          <a:effectRef idx="2">
+            <a:schemeClr val="accent1"/>
+          </a:effectRef>
+          <a:fontRef idx="minor">
+            <a:schemeClr val="lt1"/>
+          </a:fontRef>
+        </p:style>
+        <p:txBody>
+          <a:bodyPr rtlCol="0" anchor="ctr"/>
+          <a:lstStyle/>
+          <a:p>
+            <a:pPr algn="ctr"/>
+          </a:p>
+        </p:txBody>
+      </p:sp>
+      <p:sp>
+        <p:nvSpPr>
+          <p:cNvPr id="4" name="Rectangle 3"/>
+          <p:cNvSpPr/>
+          <p:nvPr/>
+        </p:nvSpPr>
+        <p:spPr>
+          <a:xfrm>
+            <a:off x="320040" y="0"/>
+            <a:ext cx="11871655" cy="502920"/>
+          </a:xfrm>
+          <a:prstGeom prst="rect">
+            <a:avLst/>
+          </a:prstGeom>
+          <a:solidFill>
+            <a:srgbClr val="E9DEC9"/>
+          </a:solidFill>
+          <a:ln>
+            <a:noFill/>
+          </a:ln>
+          <a:effectLst/>
+        </p:spPr>
+        <p:style>
+          <a:lnRef idx="1">
+            <a:schemeClr val="accent1"/>
+          </a:lnRef>
+          <a:fillRef idx="3">
+            <a:schemeClr val="accent1"/>
+          </a:fillRef>
+          <a:effectRef idx="2">
+            <a:schemeClr val="accent1"/>
+          </a:effectRef>
+          <a:fontRef idx="minor">
+            <a:schemeClr val="lt1"/>
+          </a:fontRef>
+        </p:style>
+        <p:txBody>
+          <a:bodyPr rtlCol="0" anchor="ctr"/>
+          <a:lstStyle/>
+          <a:p>
+            <a:pPr algn="ctr"/>
+          </a:p>
+        </p:txBody>
+      </p:sp>
+      <p:sp>
+        <p:nvSpPr>
+          <p:cNvPr id="5" name="TextBox 4"/>
+          <p:cNvSpPr txBox="1"/>
+          <p:nvPr/>
+        </p:nvSpPr>
+        <p:spPr>
+          <a:xfrm>
+            <a:off x="731520" y="91440"/>
+            <a:ext cx="8229600" cy="320040"/>
+          </a:xfrm>
+          <a:prstGeom prst="rect">
+            <a:avLst/>
+          </a:prstGeom>
+          <a:noFill/>
+        </p:spPr>
+        <p:txBody>
+          <a:bodyPr wrap="square" lIns="0" rIns="0" tIns="0" bIns="0" anchor="ctr">
+            <a:spAutoFit/>
+          </a:bodyPr>
+          <a:lstStyle/>
+          <a:p>
+            <a:pPr algn="l"/>
+            <a:r>
+              <a:rPr sz="1100" b="1">
+                <a:solidFill>
+                  <a:srgbClr val="B85C38"/>
+                </a:solidFill>
+                <a:latin typeface="Calibri"/>
+              </a:rPr>
+              <a:t>ANEXO TÉCNICO · A.2</a:t>
+            </a:r>
+          </a:p>
+        </p:txBody>
+      </p:sp>
+      <p:sp>
+        <p:nvSpPr>
+          <p:cNvPr id="6" name="TextBox 5"/>
+          <p:cNvSpPr txBox="1"/>
+          <p:nvPr/>
+        </p:nvSpPr>
+        <p:spPr>
+          <a:xfrm>
+            <a:off x="10698480" y="91440"/>
+            <a:ext cx="1188720" cy="320040"/>
+          </a:xfrm>
+          <a:prstGeom prst="rect">
+            <a:avLst/>
+          </a:prstGeom>
+          <a:noFill/>
+        </p:spPr>
+        <p:txBody>
+          <a:bodyPr wrap="square" lIns="0" rIns="0" tIns="0" bIns="0" anchor="ctr">
+            <a:spAutoFit/>
+          </a:bodyPr>
+          <a:lstStyle/>
+          <a:p>
+            <a:pPr algn="r"/>
+            <a:r>
+              <a:rPr sz="900" b="0">
+                <a:solidFill>
+                  <a:srgbClr val="555555"/>
+                </a:solidFill>
+                <a:latin typeface="Calibri"/>
+              </a:rPr>
+              <a:t>Raíces Vivas · Entrega Final · CENFOTEC</a:t>
+            </a:r>
+          </a:p>
+        </p:txBody>
+      </p:sp>
+      <p:sp>
+        <p:nvSpPr>
+          <p:cNvPr id="7" name="TextBox 6"/>
+          <p:cNvSpPr txBox="1"/>
+          <p:nvPr/>
+        </p:nvSpPr>
+        <p:spPr>
+          <a:xfrm>
+            <a:off x="731520" y="640080"/>
+            <a:ext cx="10607040" cy="685800"/>
+          </a:xfrm>
+          <a:prstGeom prst="rect">
+            <a:avLst/>
+          </a:prstGeom>
+          <a:noFill/>
+        </p:spPr>
+        <p:txBody>
+          <a:bodyPr wrap="square" lIns="0" rIns="0" tIns="0" bIns="0" anchor="t">
+            <a:spAutoFit/>
+          </a:bodyPr>
+          <a:lstStyle/>
+          <a:p>
+            <a:pPr algn="l"/>
+            <a:r>
+              <a:rPr sz="3000" b="1">
+                <a:solidFill>
+                  <a:srgbClr val="133A32"/>
+                </a:solidFill>
+                <a:latin typeface="Calibri"/>
+              </a:rPr>
+              <a:t>DFD Nivel 1 — Descomposición funcional</a:t>
+            </a:r>
+          </a:p>
+        </p:txBody>
+      </p:sp>
+      <p:sp>
+        <p:nvSpPr>
+          <p:cNvPr id="8" name="TextBox 7"/>
+          <p:cNvSpPr txBox="1"/>
+          <p:nvPr/>
+        </p:nvSpPr>
+        <p:spPr>
+          <a:xfrm>
+            <a:off x="731520" y="1325880"/>
+            <a:ext cx="10607040" cy="320040"/>
+          </a:xfrm>
+          <a:prstGeom prst="rect">
+            <a:avLst/>
+          </a:prstGeom>
+          <a:noFill/>
+        </p:spPr>
+        <p:txBody>
+          <a:bodyPr wrap="square" lIns="0" rIns="0" tIns="0" bIns="0" anchor="t">
+            <a:spAutoFit/>
+          </a:bodyPr>
+          <a:lstStyle/>
+          <a:p>
+            <a:pPr algn="l"/>
+            <a:r>
+              <a:rPr sz="1400" b="0">
+                <a:solidFill>
+                  <a:srgbClr val="4E6E66"/>
+                </a:solidFill>
+                <a:latin typeface="Calibri"/>
+              </a:rPr>
+              <a:t>Procesos · almacenes · flujos</a:t>
+            </a:r>
+          </a:p>
+        </p:txBody>
+      </p:sp>
+      <p:sp>
+        <p:nvSpPr>
+          <p:cNvPr id="9" name="Rectangle 8"/>
+          <p:cNvSpPr/>
+          <p:nvPr/>
+        </p:nvSpPr>
+        <p:spPr>
+          <a:xfrm>
+            <a:off x="685800" y="1828800"/>
+            <a:ext cx="10789920" cy="4023360"/>
+          </a:xfrm>
+          <a:prstGeom prst="rect">
+            <a:avLst/>
+          </a:prstGeom>
+          <a:solidFill>
+            <a:srgbClr val="FFFFFF"/>
+          </a:solidFill>
+          <a:ln w="9525">
+            <a:solidFill>
+              <a:srgbClr val="E9DEC9"/>
+            </a:solidFill>
+          </a:ln>
+          <a:effectLst/>
+        </p:spPr>
+        <p:style>
+          <a:lnRef idx="1">
+            <a:schemeClr val="accent1"/>
+          </a:lnRef>
+          <a:fillRef idx="3">
+            <a:schemeClr val="accent1"/>
+          </a:fillRef>
+          <a:effectRef idx="2">
+            <a:schemeClr val="accent1"/>
+          </a:effectRef>
+          <a:fontRef idx="minor">
+            <a:schemeClr val="lt1"/>
+          </a:fontRef>
+        </p:style>
+        <p:txBody>
+          <a:bodyPr rtlCol="0" anchor="ctr"/>
+          <a:lstStyle/>
+          <a:p>
+            <a:pPr algn="ctr"/>
+          </a:p>
+        </p:txBody>
+      </p:sp>
+      <p:pic>
+        <p:nvPicPr>
+          <p:cNvPr id="10" name="Picture 9" descr="diagram_dfd_nivel1.png"/>
+          <p:cNvPicPr>
+            <a:picLocks noChangeAspect="1"/>
+          </p:cNvPicPr>
+          <p:nvPr/>
+        </p:nvPicPr>
+        <p:blipFill>
+          <a:blip r:embed="rId2"/>
+          <a:stretch>
+            <a:fillRect/>
+          </a:stretch>
+        </p:blipFill>
+        <p:spPr>
+          <a:xfrm>
+            <a:off x="3184029" y="1929384"/>
+            <a:ext cx="5793461" cy="3822191"/>
+          </a:xfrm>
+          <a:prstGeom prst="rect">
+            <a:avLst/>
+          </a:prstGeom>
+        </p:spPr>
+      </p:pic>
+      <p:sp>
+        <p:nvSpPr>
+          <p:cNvPr id="11" name="Rectangle 10"/>
+          <p:cNvSpPr/>
+          <p:nvPr/>
+        </p:nvSpPr>
+        <p:spPr>
+          <a:xfrm>
+            <a:off x="320040" y="5989320"/>
+            <a:ext cx="11871655" cy="685800"/>
+          </a:xfrm>
+          <a:prstGeom prst="rect">
+            <a:avLst/>
+          </a:prstGeom>
+          <a:solidFill>
+            <a:srgbClr val="133A32"/>
+          </a:solidFill>
+          <a:ln>
+            <a:noFill/>
+          </a:ln>
+          <a:effectLst/>
+        </p:spPr>
+        <p:style>
+          <a:lnRef idx="1">
+            <a:schemeClr val="accent1"/>
+          </a:lnRef>
+          <a:fillRef idx="3">
+            <a:schemeClr val="accent1"/>
+          </a:fillRef>
+          <a:effectRef idx="2">
+            <a:schemeClr val="accent1"/>
+          </a:effectRef>
+          <a:fontRef idx="minor">
+            <a:schemeClr val="lt1"/>
+          </a:fontRef>
+        </p:style>
+        <p:txBody>
+          <a:bodyPr rtlCol="0" anchor="ctr"/>
+          <a:lstStyle/>
+          <a:p>
+            <a:pPr algn="ctr"/>
+          </a:p>
+        </p:txBody>
+      </p:sp>
+      <p:sp>
+        <p:nvSpPr>
+          <p:cNvPr id="12" name="TextBox 11"/>
+          <p:cNvSpPr txBox="1"/>
+          <p:nvPr/>
+        </p:nvSpPr>
+        <p:spPr>
+          <a:xfrm>
+            <a:off x="731520" y="6035040"/>
+            <a:ext cx="10607040" cy="594360"/>
+          </a:xfrm>
+          <a:prstGeom prst="rect">
+            <a:avLst/>
+          </a:prstGeom>
+          <a:noFill/>
+        </p:spPr>
+        <p:txBody>
+          <a:bodyPr wrap="square" lIns="0" rIns="0" tIns="0" bIns="0" anchor="ctr">
+            <a:spAutoFit/>
+          </a:bodyPr>
+          <a:lstStyle/>
+          <a:p>
+            <a:pPr algn="l"/>
+            <a:r>
+              <a:rPr sz="1100" b="0">
+                <a:solidFill>
+                  <a:srgbClr val="F5EDE0"/>
+                </a:solidFill>
+                <a:latin typeface="Calibri"/>
+              </a:rPr>
+              <a:t>Cuatro procesos hijos (EDU · SAB · SAL · Transversales) y cinco almacenes de datos (D1 catálogo, D2 PouchDB, D3 log auditoría, D4 i18n, D5 CouchDB). Representa la base offline-first del sistema.</a:t>
+            </a:r>
+          </a:p>
+        </p:txBody>
+      </p:sp>
+      <p:pic>
+        <p:nvPicPr>
+          <p:cNvPr id="13" name="Picture 12" descr="logo-cenfotec-200x200.png"/>
+          <p:cNvPicPr>
+            <a:picLocks noChangeAspect="1"/>
+          </p:cNvPicPr>
+          <p:nvPr/>
+        </p:nvPicPr>
+        <p:blipFill>
+          <a:blip r:embed="rId3"/>
+          <a:stretch>
+            <a:fillRect/>
+          </a:stretch>
+        </p:blipFill>
+        <p:spPr>
+          <a:xfrm>
+            <a:off x="11430000" y="6172200"/>
+            <a:ext cx="411480" cy="411480"/>
+          </a:xfrm>
+          <a:prstGeom prst="rect">
+            <a:avLst/>
+          </a:prstGeom>
+        </p:spPr>
+      </p:pic>
+    </p:spTree>
+  </p:cSld>
+  <p:clrMapOvr>
+    <a:masterClrMapping/>
+  </p:clrMapOvr>
+</p:sld>
+</file>
+
+<file path=ppt/slides/slide17.xml><?xml version="1.0" encoding="utf-8"?>
+<p:sld xmlns:a="http://schemas.openxmlformats.org/drawingml/2006/main" xmlns:p="http://schemas.openxmlformats.org/presentationml/2006/main" xmlns:r="http://schemas.openxmlformats.org/officeDocument/2006/relationships">
+  <p:cSld>
+    <p:spTree>
+      <p:nvGrpSpPr>
+        <p:cNvPr id="1" name=""/>
+        <p:cNvGrpSpPr/>
+        <p:nvPr/>
+      </p:nvGrpSpPr>
+      <p:grpSpPr/>
+      <p:sp>
+        <p:nvSpPr>
+          <p:cNvPr id="2" name="Rectangle 1"/>
+          <p:cNvSpPr/>
+          <p:nvPr/>
+        </p:nvSpPr>
+        <p:spPr>
+          <a:xfrm>
+            <a:off x="0" y="0"/>
+            <a:ext cx="12191695" cy="6858000"/>
+          </a:xfrm>
+          <a:prstGeom prst="rect">
+            <a:avLst/>
+          </a:prstGeom>
+          <a:solidFill>
+            <a:srgbClr val="F5EDE0"/>
+          </a:solidFill>
+          <a:ln>
+            <a:noFill/>
+          </a:ln>
+          <a:effectLst/>
+        </p:spPr>
+        <p:style>
+          <a:lnRef idx="1">
+            <a:schemeClr val="accent1"/>
+          </a:lnRef>
+          <a:fillRef idx="3">
+            <a:schemeClr val="accent1"/>
+          </a:fillRef>
+          <a:effectRef idx="2">
+            <a:schemeClr val="accent1"/>
+          </a:effectRef>
+          <a:fontRef idx="minor">
+            <a:schemeClr val="lt1"/>
+          </a:fontRef>
+        </p:style>
+        <p:txBody>
+          <a:bodyPr rtlCol="0" anchor="ctr"/>
+          <a:lstStyle/>
+          <a:p>
+            <a:pPr algn="ctr"/>
+          </a:p>
+        </p:txBody>
+      </p:sp>
+      <p:sp>
+        <p:nvSpPr>
+          <p:cNvPr id="3" name="Rectangle 2"/>
+          <p:cNvSpPr/>
+          <p:nvPr/>
+        </p:nvSpPr>
+        <p:spPr>
+          <a:xfrm>
+            <a:off x="0" y="0"/>
+            <a:ext cx="320040" cy="6858000"/>
+          </a:xfrm>
+          <a:prstGeom prst="rect">
+            <a:avLst/>
+          </a:prstGeom>
+          <a:solidFill>
+            <a:srgbClr val="133A32"/>
+          </a:solidFill>
+          <a:ln>
+            <a:noFill/>
+          </a:ln>
+          <a:effectLst/>
+        </p:spPr>
+        <p:style>
+          <a:lnRef idx="1">
+            <a:schemeClr val="accent1"/>
+          </a:lnRef>
+          <a:fillRef idx="3">
+            <a:schemeClr val="accent1"/>
+          </a:fillRef>
+          <a:effectRef idx="2">
+            <a:schemeClr val="accent1"/>
+          </a:effectRef>
+          <a:fontRef idx="minor">
+            <a:schemeClr val="lt1"/>
+          </a:fontRef>
+        </p:style>
+        <p:txBody>
+          <a:bodyPr rtlCol="0" anchor="ctr"/>
+          <a:lstStyle/>
+          <a:p>
+            <a:pPr algn="ctr"/>
+          </a:p>
+        </p:txBody>
+      </p:sp>
+      <p:sp>
+        <p:nvSpPr>
+          <p:cNvPr id="4" name="Rectangle 3"/>
+          <p:cNvSpPr/>
+          <p:nvPr/>
+        </p:nvSpPr>
+        <p:spPr>
+          <a:xfrm>
+            <a:off x="320040" y="0"/>
+            <a:ext cx="11871655" cy="502920"/>
+          </a:xfrm>
+          <a:prstGeom prst="rect">
+            <a:avLst/>
+          </a:prstGeom>
+          <a:solidFill>
+            <a:srgbClr val="E9DEC9"/>
+          </a:solidFill>
+          <a:ln>
+            <a:noFill/>
+          </a:ln>
+          <a:effectLst/>
+        </p:spPr>
+        <p:style>
+          <a:lnRef idx="1">
+            <a:schemeClr val="accent1"/>
+          </a:lnRef>
+          <a:fillRef idx="3">
+            <a:schemeClr val="accent1"/>
+          </a:fillRef>
+          <a:effectRef idx="2">
+            <a:schemeClr val="accent1"/>
+          </a:effectRef>
+          <a:fontRef idx="minor">
+            <a:schemeClr val="lt1"/>
+          </a:fontRef>
+        </p:style>
+        <p:txBody>
+          <a:bodyPr rtlCol="0" anchor="ctr"/>
+          <a:lstStyle/>
+          <a:p>
+            <a:pPr algn="ctr"/>
+          </a:p>
+        </p:txBody>
+      </p:sp>
+      <p:sp>
+        <p:nvSpPr>
+          <p:cNvPr id="5" name="TextBox 4"/>
+          <p:cNvSpPr txBox="1"/>
+          <p:nvPr/>
+        </p:nvSpPr>
+        <p:spPr>
+          <a:xfrm>
+            <a:off x="731520" y="91440"/>
+            <a:ext cx="8229600" cy="320040"/>
+          </a:xfrm>
+          <a:prstGeom prst="rect">
+            <a:avLst/>
+          </a:prstGeom>
+          <a:noFill/>
+        </p:spPr>
+        <p:txBody>
+          <a:bodyPr wrap="square" lIns="0" rIns="0" tIns="0" bIns="0" anchor="ctr">
+            <a:spAutoFit/>
+          </a:bodyPr>
+          <a:lstStyle/>
+          <a:p>
+            <a:pPr algn="l"/>
+            <a:r>
+              <a:rPr sz="1100" b="1">
+                <a:solidFill>
+                  <a:srgbClr val="B85C38"/>
+                </a:solidFill>
+                <a:latin typeface="Calibri"/>
+              </a:rPr>
+              <a:t>ANEXO TRAZABILIDAD · A.3</a:t>
+            </a:r>
+          </a:p>
+        </p:txBody>
+      </p:sp>
+      <p:sp>
+        <p:nvSpPr>
+          <p:cNvPr id="6" name="TextBox 5"/>
+          <p:cNvSpPr txBox="1"/>
+          <p:nvPr/>
+        </p:nvSpPr>
+        <p:spPr>
+          <a:xfrm>
+            <a:off x="10698480" y="91440"/>
+            <a:ext cx="1188720" cy="320040"/>
+          </a:xfrm>
+          <a:prstGeom prst="rect">
+            <a:avLst/>
+          </a:prstGeom>
+          <a:noFill/>
+        </p:spPr>
+        <p:txBody>
+          <a:bodyPr wrap="square" lIns="0" rIns="0" tIns="0" bIns="0" anchor="ctr">
+            <a:spAutoFit/>
+          </a:bodyPr>
+          <a:lstStyle/>
+          <a:p>
+            <a:pPr algn="r"/>
+            <a:r>
+              <a:rPr sz="900" b="0">
+                <a:solidFill>
+                  <a:srgbClr val="555555"/>
+                </a:solidFill>
+                <a:latin typeface="Calibri"/>
+              </a:rPr>
+              <a:t>Raíces Vivas · Entrega Final · CENFOTEC</a:t>
+            </a:r>
+          </a:p>
+        </p:txBody>
+      </p:sp>
+      <p:sp>
+        <p:nvSpPr>
+          <p:cNvPr id="7" name="TextBox 6"/>
+          <p:cNvSpPr txBox="1"/>
+          <p:nvPr/>
+        </p:nvSpPr>
+        <p:spPr>
+          <a:xfrm>
+            <a:off x="731520" y="640080"/>
+            <a:ext cx="10607040" cy="685800"/>
+          </a:xfrm>
+          <a:prstGeom prst="rect">
+            <a:avLst/>
+          </a:prstGeom>
+          <a:noFill/>
+        </p:spPr>
+        <p:txBody>
+          <a:bodyPr wrap="square" lIns="0" rIns="0" tIns="0" bIns="0" anchor="t">
+            <a:spAutoFit/>
+          </a:bodyPr>
+          <a:lstStyle/>
+          <a:p>
+            <a:pPr algn="l"/>
+            <a:r>
+              <a:rPr sz="3000" b="1">
+                <a:solidFill>
+                  <a:srgbClr val="133A32"/>
+                </a:solidFill>
+                <a:latin typeface="Calibri"/>
+              </a:rPr>
+              <a:t>Casos de Uso — Diagrama UML</a:t>
+            </a:r>
+          </a:p>
+        </p:txBody>
+      </p:sp>
+      <p:sp>
+        <p:nvSpPr>
+          <p:cNvPr id="8" name="TextBox 7"/>
+          <p:cNvSpPr txBox="1"/>
+          <p:nvPr/>
+        </p:nvSpPr>
+        <p:spPr>
+          <a:xfrm>
+            <a:off x="731520" y="1325880"/>
+            <a:ext cx="10607040" cy="320040"/>
+          </a:xfrm>
+          <a:prstGeom prst="rect">
+            <a:avLst/>
+          </a:prstGeom>
+          <a:noFill/>
+        </p:spPr>
+        <p:txBody>
+          <a:bodyPr wrap="square" lIns="0" rIns="0" tIns="0" bIns="0" anchor="t">
+            <a:spAutoFit/>
+          </a:bodyPr>
+          <a:lstStyle/>
+          <a:p>
+            <a:pPr algn="l"/>
+            <a:r>
+              <a:rPr sz="1400" b="0">
+                <a:solidFill>
+                  <a:srgbClr val="4E6E66"/>
+                </a:solidFill>
+                <a:latin typeface="Calibri"/>
+              </a:rPr>
+              <a:t>23 casos de uso · 4 módulos</a:t>
+            </a:r>
+          </a:p>
+        </p:txBody>
+      </p:sp>
+      <p:sp>
+        <p:nvSpPr>
+          <p:cNvPr id="9" name="Rectangle 8"/>
+          <p:cNvSpPr/>
+          <p:nvPr/>
+        </p:nvSpPr>
+        <p:spPr>
+          <a:xfrm>
+            <a:off x="685800" y="1828800"/>
+            <a:ext cx="10789920" cy="4023360"/>
+          </a:xfrm>
+          <a:prstGeom prst="rect">
+            <a:avLst/>
+          </a:prstGeom>
+          <a:solidFill>
+            <a:srgbClr val="FFFFFF"/>
+          </a:solidFill>
+          <a:ln w="9525">
+            <a:solidFill>
+              <a:srgbClr val="E9DEC9"/>
+            </a:solidFill>
+          </a:ln>
+          <a:effectLst/>
+        </p:spPr>
+        <p:style>
+          <a:lnRef idx="1">
+            <a:schemeClr val="accent1"/>
+          </a:lnRef>
+          <a:fillRef idx="3">
+            <a:schemeClr val="accent1"/>
+          </a:fillRef>
+          <a:effectRef idx="2">
+            <a:schemeClr val="accent1"/>
+          </a:effectRef>
+          <a:fontRef idx="minor">
+            <a:schemeClr val="lt1"/>
+          </a:fontRef>
+        </p:style>
+        <p:txBody>
+          <a:bodyPr rtlCol="0" anchor="ctr"/>
+          <a:lstStyle/>
+          <a:p>
+            <a:pPr algn="ctr"/>
+          </a:p>
+        </p:txBody>
+      </p:sp>
+      <p:pic>
+        <p:nvPicPr>
+          <p:cNvPr id="10" name="Picture 9" descr="diagram_usecase.png"/>
+          <p:cNvPicPr>
+            <a:picLocks noChangeAspect="1"/>
+          </p:cNvPicPr>
+          <p:nvPr/>
+        </p:nvPicPr>
+        <p:blipFill>
+          <a:blip r:embed="rId2"/>
+          <a:stretch>
+            <a:fillRect/>
+          </a:stretch>
+        </p:blipFill>
+        <p:spPr>
+          <a:xfrm>
+            <a:off x="3682521" y="1929384"/>
+            <a:ext cx="4796476" cy="3822191"/>
+          </a:xfrm>
+          <a:prstGeom prst="rect">
+            <a:avLst/>
+          </a:prstGeom>
+        </p:spPr>
+      </p:pic>
+      <p:sp>
+        <p:nvSpPr>
+          <p:cNvPr id="11" name="Rectangle 10"/>
+          <p:cNvSpPr/>
+          <p:nvPr/>
+        </p:nvSpPr>
+        <p:spPr>
+          <a:xfrm>
+            <a:off x="320040" y="5989320"/>
+            <a:ext cx="11871655" cy="685800"/>
+          </a:xfrm>
+          <a:prstGeom prst="rect">
+            <a:avLst/>
+          </a:prstGeom>
+          <a:solidFill>
+            <a:srgbClr val="133A32"/>
+          </a:solidFill>
+          <a:ln>
+            <a:noFill/>
+          </a:ln>
+          <a:effectLst/>
+        </p:spPr>
+        <p:style>
+          <a:lnRef idx="1">
+            <a:schemeClr val="accent1"/>
+          </a:lnRef>
+          <a:fillRef idx="3">
+            <a:schemeClr val="accent1"/>
+          </a:fillRef>
+          <a:effectRef idx="2">
+            <a:schemeClr val="accent1"/>
+          </a:effectRef>
+          <a:fontRef idx="minor">
+            <a:schemeClr val="lt1"/>
+          </a:fontRef>
+        </p:style>
+        <p:txBody>
+          <a:bodyPr rtlCol="0" anchor="ctr"/>
+          <a:lstStyle/>
+          <a:p>
+            <a:pPr algn="ctr"/>
+          </a:p>
+        </p:txBody>
+      </p:sp>
+      <p:sp>
+        <p:nvSpPr>
+          <p:cNvPr id="12" name="TextBox 11"/>
+          <p:cNvSpPr txBox="1"/>
+          <p:nvPr/>
+        </p:nvSpPr>
+        <p:spPr>
+          <a:xfrm>
+            <a:off x="731520" y="6035040"/>
+            <a:ext cx="10607040" cy="594360"/>
+          </a:xfrm>
+          <a:prstGeom prst="rect">
+            <a:avLst/>
+          </a:prstGeom>
+          <a:noFill/>
+        </p:spPr>
+        <p:txBody>
+          <a:bodyPr wrap="square" lIns="0" rIns="0" tIns="0" bIns="0" anchor="ctr">
+            <a:spAutoFit/>
+          </a:bodyPr>
+          <a:lstStyle/>
+          <a:p>
+            <a:pPr algn="l"/>
+            <a:r>
+              <a:rPr sz="1100" b="0">
+                <a:solidFill>
+                  <a:srgbClr val="F5EDE0"/>
+                </a:solidFill>
+                <a:latin typeface="Calibri"/>
+              </a:rPr>
+              <a:t>Actores (docente · estudiante · portador · consejo · ATAP · admin) conectados a los 23 casos de uso, agrupados por módulo EDU/SAB/SAL/TRANS. Base de la matriz RF↔CU del proyecto.</a:t>
+            </a:r>
+          </a:p>
+        </p:txBody>
+      </p:sp>
+      <p:pic>
+        <p:nvPicPr>
+          <p:cNvPr id="13" name="Picture 12" descr="logo-cenfotec-200x200.png"/>
+          <p:cNvPicPr>
+            <a:picLocks noChangeAspect="1"/>
+          </p:cNvPicPr>
+          <p:nvPr/>
+        </p:nvPicPr>
+        <p:blipFill>
+          <a:blip r:embed="rId3"/>
+          <a:stretch>
+            <a:fillRect/>
+          </a:stretch>
+        </p:blipFill>
+        <p:spPr>
+          <a:xfrm>
+            <a:off x="11430000" y="6172200"/>
+            <a:ext cx="411480" cy="411480"/>
+          </a:xfrm>
+          <a:prstGeom prst="rect">
+            <a:avLst/>
+          </a:prstGeom>
+        </p:spPr>
+      </p:pic>
+    </p:spTree>
+  </p:cSld>
+  <p:clrMapOvr>
+    <a:masterClrMapping/>
+  </p:clrMapOvr>
+</p:sld>
+</file>
+
+<file path=ppt/slides/slide18.xml><?xml version="1.0" encoding="utf-8"?>
+<p:sld xmlns:a="http://schemas.openxmlformats.org/drawingml/2006/main" xmlns:p="http://schemas.openxmlformats.org/presentationml/2006/main" xmlns:r="http://schemas.openxmlformats.org/officeDocument/2006/relationships">
+  <p:cSld>
+    <p:spTree>
+      <p:nvGrpSpPr>
+        <p:cNvPr id="1" name=""/>
+        <p:cNvGrpSpPr/>
+        <p:nvPr/>
+      </p:nvGrpSpPr>
+      <p:grpSpPr/>
+      <p:sp>
+        <p:nvSpPr>
+          <p:cNvPr id="2" name="Rectangle 1"/>
+          <p:cNvSpPr/>
+          <p:nvPr/>
+        </p:nvSpPr>
+        <p:spPr>
+          <a:xfrm>
+            <a:off x="0" y="0"/>
+            <a:ext cx="12191695" cy="6858000"/>
+          </a:xfrm>
+          <a:prstGeom prst="rect">
+            <a:avLst/>
+          </a:prstGeom>
+          <a:solidFill>
+            <a:srgbClr val="F5EDE0"/>
+          </a:solidFill>
+          <a:ln>
+            <a:noFill/>
+          </a:ln>
+          <a:effectLst/>
+        </p:spPr>
+        <p:style>
+          <a:lnRef idx="1">
+            <a:schemeClr val="accent1"/>
+          </a:lnRef>
+          <a:fillRef idx="3">
+            <a:schemeClr val="accent1"/>
+          </a:fillRef>
+          <a:effectRef idx="2">
+            <a:schemeClr val="accent1"/>
+          </a:effectRef>
+          <a:fontRef idx="minor">
+            <a:schemeClr val="lt1"/>
+          </a:fontRef>
+        </p:style>
+        <p:txBody>
+          <a:bodyPr rtlCol="0" anchor="ctr"/>
+          <a:lstStyle/>
+          <a:p>
+            <a:pPr algn="ctr"/>
+          </a:p>
+        </p:txBody>
+      </p:sp>
+      <p:sp>
+        <p:nvSpPr>
+          <p:cNvPr id="3" name="Rectangle 2"/>
+          <p:cNvSpPr/>
+          <p:nvPr/>
+        </p:nvSpPr>
+        <p:spPr>
+          <a:xfrm>
+            <a:off x="0" y="0"/>
+            <a:ext cx="320040" cy="6858000"/>
+          </a:xfrm>
+          <a:prstGeom prst="rect">
+            <a:avLst/>
+          </a:prstGeom>
+          <a:solidFill>
+            <a:srgbClr val="133A32"/>
+          </a:solidFill>
+          <a:ln>
+            <a:noFill/>
+          </a:ln>
+          <a:effectLst/>
+        </p:spPr>
+        <p:style>
+          <a:lnRef idx="1">
+            <a:schemeClr val="accent1"/>
+          </a:lnRef>
+          <a:fillRef idx="3">
+            <a:schemeClr val="accent1"/>
+          </a:fillRef>
+          <a:effectRef idx="2">
+            <a:schemeClr val="accent1"/>
+          </a:effectRef>
+          <a:fontRef idx="minor">
+            <a:schemeClr val="lt1"/>
+          </a:fontRef>
+        </p:style>
+        <p:txBody>
+          <a:bodyPr rtlCol="0" anchor="ctr"/>
+          <a:lstStyle/>
+          <a:p>
+            <a:pPr algn="ctr"/>
+          </a:p>
+        </p:txBody>
+      </p:sp>
+      <p:sp>
+        <p:nvSpPr>
+          <p:cNvPr id="4" name="Rectangle 3"/>
+          <p:cNvSpPr/>
+          <p:nvPr/>
+        </p:nvSpPr>
+        <p:spPr>
+          <a:xfrm>
+            <a:off x="320040" y="0"/>
+            <a:ext cx="11871655" cy="502920"/>
+          </a:xfrm>
+          <a:prstGeom prst="rect">
+            <a:avLst/>
+          </a:prstGeom>
+          <a:solidFill>
+            <a:srgbClr val="E9DEC9"/>
+          </a:solidFill>
+          <a:ln>
+            <a:noFill/>
+          </a:ln>
+          <a:effectLst/>
+        </p:spPr>
+        <p:style>
+          <a:lnRef idx="1">
+            <a:schemeClr val="accent1"/>
+          </a:lnRef>
+          <a:fillRef idx="3">
+            <a:schemeClr val="accent1"/>
+          </a:fillRef>
+          <a:effectRef idx="2">
+            <a:schemeClr val="accent1"/>
+          </a:effectRef>
+          <a:fontRef idx="minor">
+            <a:schemeClr val="lt1"/>
+          </a:fontRef>
+        </p:style>
+        <p:txBody>
+          <a:bodyPr rtlCol="0" anchor="ctr"/>
+          <a:lstStyle/>
+          <a:p>
+            <a:pPr algn="ctr"/>
+          </a:p>
+        </p:txBody>
+      </p:sp>
+      <p:sp>
+        <p:nvSpPr>
+          <p:cNvPr id="5" name="TextBox 4"/>
+          <p:cNvSpPr txBox="1"/>
+          <p:nvPr/>
+        </p:nvSpPr>
+        <p:spPr>
+          <a:xfrm>
+            <a:off x="731520" y="91440"/>
+            <a:ext cx="8229600" cy="320040"/>
+          </a:xfrm>
+          <a:prstGeom prst="rect">
+            <a:avLst/>
+          </a:prstGeom>
+          <a:noFill/>
+        </p:spPr>
+        <p:txBody>
+          <a:bodyPr wrap="square" lIns="0" rIns="0" tIns="0" bIns="0" anchor="ctr">
+            <a:spAutoFit/>
+          </a:bodyPr>
+          <a:lstStyle/>
+          <a:p>
+            <a:pPr algn="l"/>
+            <a:r>
+              <a:rPr sz="1100" b="1">
+                <a:solidFill>
+                  <a:srgbClr val="B85C38"/>
+                </a:solidFill>
+                <a:latin typeface="Calibri"/>
+              </a:rPr>
+              <a:t>ANEXO TRAZABILIDAD · A.4</a:t>
+            </a:r>
+          </a:p>
+        </p:txBody>
+      </p:sp>
+      <p:sp>
+        <p:nvSpPr>
+          <p:cNvPr id="6" name="TextBox 5"/>
+          <p:cNvSpPr txBox="1"/>
+          <p:nvPr/>
+        </p:nvSpPr>
+        <p:spPr>
+          <a:xfrm>
+            <a:off x="10698480" y="91440"/>
+            <a:ext cx="1188720" cy="320040"/>
+          </a:xfrm>
+          <a:prstGeom prst="rect">
+            <a:avLst/>
+          </a:prstGeom>
+          <a:noFill/>
+        </p:spPr>
+        <p:txBody>
+          <a:bodyPr wrap="square" lIns="0" rIns="0" tIns="0" bIns="0" anchor="ctr">
+            <a:spAutoFit/>
+          </a:bodyPr>
+          <a:lstStyle/>
+          <a:p>
+            <a:pPr algn="r"/>
+            <a:r>
+              <a:rPr sz="900" b="0">
+                <a:solidFill>
+                  <a:srgbClr val="555555"/>
+                </a:solidFill>
+                <a:latin typeface="Calibri"/>
+              </a:rPr>
+              <a:t>Raíces Vivas · Entrega Final · CENFOTEC</a:t>
+            </a:r>
+          </a:p>
+        </p:txBody>
+      </p:sp>
+      <p:sp>
+        <p:nvSpPr>
+          <p:cNvPr id="7" name="TextBox 6"/>
+          <p:cNvSpPr txBox="1"/>
+          <p:nvPr/>
+        </p:nvSpPr>
+        <p:spPr>
+          <a:xfrm>
+            <a:off x="731520" y="640080"/>
+            <a:ext cx="10607040" cy="685800"/>
+          </a:xfrm>
+          <a:prstGeom prst="rect">
+            <a:avLst/>
+          </a:prstGeom>
+          <a:noFill/>
+        </p:spPr>
+        <p:txBody>
+          <a:bodyPr wrap="square" lIns="0" rIns="0" tIns="0" bIns="0" anchor="t">
+            <a:spAutoFit/>
+          </a:bodyPr>
+          <a:lstStyle/>
+          <a:p>
+            <a:pPr algn="l"/>
+            <a:r>
+              <a:rPr sz="3000" b="1">
+                <a:solidFill>
+                  <a:srgbClr val="133A32"/>
+                </a:solidFill>
+                <a:latin typeface="Calibri"/>
+              </a:rPr>
+              <a:t>Actores × Módulos — Matriz de responsabilidades</a:t>
+            </a:r>
+          </a:p>
+        </p:txBody>
+      </p:sp>
+      <p:sp>
+        <p:nvSpPr>
+          <p:cNvPr id="8" name="TextBox 7"/>
+          <p:cNvSpPr txBox="1"/>
+          <p:nvPr/>
+        </p:nvSpPr>
+        <p:spPr>
+          <a:xfrm>
+            <a:off x="731520" y="1325880"/>
+            <a:ext cx="10607040" cy="320040"/>
+          </a:xfrm>
+          <a:prstGeom prst="rect">
+            <a:avLst/>
+          </a:prstGeom>
+          <a:noFill/>
+        </p:spPr>
+        <p:txBody>
+          <a:bodyPr wrap="square" lIns="0" rIns="0" tIns="0" bIns="0" anchor="t">
+            <a:spAutoFit/>
+          </a:bodyPr>
+          <a:lstStyle/>
+          <a:p>
+            <a:pPr algn="l"/>
+            <a:r>
+              <a:rPr sz="1400" b="0">
+                <a:solidFill>
+                  <a:srgbClr val="4E6E66"/>
+                </a:solidFill>
+                <a:latin typeface="Calibri"/>
+              </a:rPr>
+              <a:t>Quién interactúa con qué</a:t>
+            </a:r>
+          </a:p>
+        </p:txBody>
+      </p:sp>
+      <p:sp>
+        <p:nvSpPr>
+          <p:cNvPr id="9" name="Rectangle 8"/>
+          <p:cNvSpPr/>
+          <p:nvPr/>
+        </p:nvSpPr>
+        <p:spPr>
+          <a:xfrm>
+            <a:off x="685800" y="1828800"/>
+            <a:ext cx="10789920" cy="4023360"/>
+          </a:xfrm>
+          <a:prstGeom prst="rect">
+            <a:avLst/>
+          </a:prstGeom>
+          <a:solidFill>
+            <a:srgbClr val="FFFFFF"/>
+          </a:solidFill>
+          <a:ln w="9525">
+            <a:solidFill>
+              <a:srgbClr val="E9DEC9"/>
+            </a:solidFill>
+          </a:ln>
+          <a:effectLst/>
+        </p:spPr>
+        <p:style>
+          <a:lnRef idx="1">
+            <a:schemeClr val="accent1"/>
+          </a:lnRef>
+          <a:fillRef idx="3">
+            <a:schemeClr val="accent1"/>
+          </a:fillRef>
+          <a:effectRef idx="2">
+            <a:schemeClr val="accent1"/>
+          </a:effectRef>
+          <a:fontRef idx="minor">
+            <a:schemeClr val="lt1"/>
+          </a:fontRef>
+        </p:style>
+        <p:txBody>
+          <a:bodyPr rtlCol="0" anchor="ctr"/>
+          <a:lstStyle/>
+          <a:p>
+            <a:pPr algn="ctr"/>
+          </a:p>
+        </p:txBody>
+      </p:sp>
+      <p:pic>
+        <p:nvPicPr>
+          <p:cNvPr id="10" name="Picture 9" descr="diagram_actor_modulo.png"/>
+          <p:cNvPicPr>
+            <a:picLocks noChangeAspect="1"/>
+          </p:cNvPicPr>
+          <p:nvPr/>
+        </p:nvPicPr>
+        <p:blipFill>
+          <a:blip r:embed="rId2"/>
+          <a:stretch>
+            <a:fillRect/>
+          </a:stretch>
+        </p:blipFill>
+        <p:spPr>
+          <a:xfrm>
+            <a:off x="2411455" y="1929384"/>
+            <a:ext cx="7338608" cy="3822191"/>
+          </a:xfrm>
+          <a:prstGeom prst="rect">
+            <a:avLst/>
+          </a:prstGeom>
+        </p:spPr>
+      </p:pic>
+      <p:sp>
+        <p:nvSpPr>
+          <p:cNvPr id="11" name="Rectangle 10"/>
+          <p:cNvSpPr/>
+          <p:nvPr/>
+        </p:nvSpPr>
+        <p:spPr>
+          <a:xfrm>
+            <a:off x="320040" y="5989320"/>
+            <a:ext cx="11871655" cy="685800"/>
+          </a:xfrm>
+          <a:prstGeom prst="rect">
+            <a:avLst/>
+          </a:prstGeom>
+          <a:solidFill>
+            <a:srgbClr val="133A32"/>
+          </a:solidFill>
+          <a:ln>
+            <a:noFill/>
+          </a:ln>
+          <a:effectLst/>
+        </p:spPr>
+        <p:style>
+          <a:lnRef idx="1">
+            <a:schemeClr val="accent1"/>
+          </a:lnRef>
+          <a:fillRef idx="3">
+            <a:schemeClr val="accent1"/>
+          </a:fillRef>
+          <a:effectRef idx="2">
+            <a:schemeClr val="accent1"/>
+          </a:effectRef>
+          <a:fontRef idx="minor">
+            <a:schemeClr val="lt1"/>
+          </a:fontRef>
+        </p:style>
+        <p:txBody>
+          <a:bodyPr rtlCol="0" anchor="ctr"/>
+          <a:lstStyle/>
+          <a:p>
+            <a:pPr algn="ctr"/>
+          </a:p>
+        </p:txBody>
+      </p:sp>
+      <p:sp>
+        <p:nvSpPr>
+          <p:cNvPr id="12" name="TextBox 11"/>
+          <p:cNvSpPr txBox="1"/>
+          <p:nvPr/>
+        </p:nvSpPr>
+        <p:spPr>
+          <a:xfrm>
+            <a:off x="731520" y="6035040"/>
+            <a:ext cx="10607040" cy="594360"/>
+          </a:xfrm>
+          <a:prstGeom prst="rect">
+            <a:avLst/>
+          </a:prstGeom>
+          <a:noFill/>
+        </p:spPr>
+        <p:txBody>
+          <a:bodyPr wrap="square" lIns="0" rIns="0" tIns="0" bIns="0" anchor="ctr">
+            <a:spAutoFit/>
+          </a:bodyPr>
+          <a:lstStyle/>
+          <a:p>
+            <a:pPr algn="l"/>
+            <a:r>
+              <a:rPr sz="1100" b="0">
+                <a:solidFill>
+                  <a:srgbClr val="F5EDE0"/>
+                </a:solidFill>
+                <a:latin typeface="Calibri"/>
+              </a:rPr>
+              <a:t>Mapeo bidireccional de los 9 actores primarios y 4 módulos funcionales. Justifica los niveles CARE y la segregación de permisos en la arquitectura.</a:t>
+            </a:r>
+          </a:p>
+        </p:txBody>
+      </p:sp>
+      <p:pic>
+        <p:nvPicPr>
+          <p:cNvPr id="13" name="Picture 12" descr="logo-cenfotec-200x200.png"/>
+          <p:cNvPicPr>
+            <a:picLocks noChangeAspect="1"/>
+          </p:cNvPicPr>
+          <p:nvPr/>
+        </p:nvPicPr>
+        <p:blipFill>
+          <a:blip r:embed="rId3"/>
+          <a:stretch>
+            <a:fillRect/>
+          </a:stretch>
+        </p:blipFill>
+        <p:spPr>
+          <a:xfrm>
+            <a:off x="11430000" y="6172200"/>
+            <a:ext cx="411480" cy="411480"/>
+          </a:xfrm>
+          <a:prstGeom prst="rect">
+            <a:avLst/>
+          </a:prstGeom>
+        </p:spPr>
+      </p:pic>
+    </p:spTree>
+  </p:cSld>
+  <p:clrMapOvr>
+    <a:masterClrMapping/>
+  </p:clrMapOvr>
+</p:sld>
+</file>
+
+<file path=ppt/slides/slide19.xml><?xml version="1.0" encoding="utf-8"?>
+<p:sld xmlns:a="http://schemas.openxmlformats.org/drawingml/2006/main" xmlns:p="http://schemas.openxmlformats.org/presentationml/2006/main" xmlns:r="http://schemas.openxmlformats.org/officeDocument/2006/relationships">
+  <p:cSld>
+    <p:spTree>
+      <p:nvGrpSpPr>
+        <p:cNvPr id="1" name=""/>
+        <p:cNvGrpSpPr/>
+        <p:nvPr/>
+      </p:nvGrpSpPr>
+      <p:grpSpPr/>
+      <p:sp>
+        <p:nvSpPr>
+          <p:cNvPr id="2" name="Rectangle 1"/>
+          <p:cNvSpPr/>
+          <p:nvPr/>
+        </p:nvSpPr>
+        <p:spPr>
+          <a:xfrm>
+            <a:off x="0" y="0"/>
+            <a:ext cx="12191695" cy="6858000"/>
+          </a:xfrm>
+          <a:prstGeom prst="rect">
+            <a:avLst/>
+          </a:prstGeom>
+          <a:solidFill>
+            <a:srgbClr val="F5EDE0"/>
+          </a:solidFill>
+          <a:ln>
+            <a:noFill/>
+          </a:ln>
+          <a:effectLst/>
+        </p:spPr>
+        <p:style>
+          <a:lnRef idx="1">
+            <a:schemeClr val="accent1"/>
+          </a:lnRef>
+          <a:fillRef idx="3">
+            <a:schemeClr val="accent1"/>
+          </a:fillRef>
+          <a:effectRef idx="2">
+            <a:schemeClr val="accent1"/>
+          </a:effectRef>
+          <a:fontRef idx="minor">
+            <a:schemeClr val="lt1"/>
+          </a:fontRef>
+        </p:style>
+        <p:txBody>
+          <a:bodyPr rtlCol="0" anchor="ctr"/>
+          <a:lstStyle/>
+          <a:p>
+            <a:pPr algn="ctr"/>
+          </a:p>
+        </p:txBody>
+      </p:sp>
+      <p:sp>
+        <p:nvSpPr>
+          <p:cNvPr id="3" name="Rectangle 2"/>
+          <p:cNvSpPr/>
+          <p:nvPr/>
+        </p:nvSpPr>
+        <p:spPr>
+          <a:xfrm>
+            <a:off x="0" y="0"/>
+            <a:ext cx="320040" cy="6858000"/>
+          </a:xfrm>
+          <a:prstGeom prst="rect">
+            <a:avLst/>
+          </a:prstGeom>
+          <a:solidFill>
+            <a:srgbClr val="133A32"/>
+          </a:solidFill>
+          <a:ln>
+            <a:noFill/>
+          </a:ln>
+          <a:effectLst/>
+        </p:spPr>
+        <p:style>
+          <a:lnRef idx="1">
+            <a:schemeClr val="accent1"/>
+          </a:lnRef>
+          <a:fillRef idx="3">
+            <a:schemeClr val="accent1"/>
+          </a:fillRef>
+          <a:effectRef idx="2">
+            <a:schemeClr val="accent1"/>
+          </a:effectRef>
+          <a:fontRef idx="minor">
+            <a:schemeClr val="lt1"/>
+          </a:fontRef>
+        </p:style>
+        <p:txBody>
+          <a:bodyPr rtlCol="0" anchor="ctr"/>
+          <a:lstStyle/>
+          <a:p>
+            <a:pPr algn="ctr"/>
+          </a:p>
+        </p:txBody>
+      </p:sp>
+      <p:sp>
+        <p:nvSpPr>
+          <p:cNvPr id="4" name="Rectangle 3"/>
+          <p:cNvSpPr/>
+          <p:nvPr/>
+        </p:nvSpPr>
+        <p:spPr>
+          <a:xfrm>
+            <a:off x="320040" y="0"/>
+            <a:ext cx="11871655" cy="502920"/>
+          </a:xfrm>
+          <a:prstGeom prst="rect">
+            <a:avLst/>
+          </a:prstGeom>
+          <a:solidFill>
+            <a:srgbClr val="E9DEC9"/>
+          </a:solidFill>
+          <a:ln>
+            <a:noFill/>
+          </a:ln>
+          <a:effectLst/>
+        </p:spPr>
+        <p:style>
+          <a:lnRef idx="1">
+            <a:schemeClr val="accent1"/>
+          </a:lnRef>
+          <a:fillRef idx="3">
+            <a:schemeClr val="accent1"/>
+          </a:fillRef>
+          <a:effectRef idx="2">
+            <a:schemeClr val="accent1"/>
+          </a:effectRef>
+          <a:fontRef idx="minor">
+            <a:schemeClr val="lt1"/>
+          </a:fontRef>
+        </p:style>
+        <p:txBody>
+          <a:bodyPr rtlCol="0" anchor="ctr"/>
+          <a:lstStyle/>
+          <a:p>
+            <a:pPr algn="ctr"/>
+          </a:p>
+        </p:txBody>
+      </p:sp>
+      <p:sp>
+        <p:nvSpPr>
+          <p:cNvPr id="5" name="TextBox 4"/>
+          <p:cNvSpPr txBox="1"/>
+          <p:nvPr/>
+        </p:nvSpPr>
+        <p:spPr>
+          <a:xfrm>
+            <a:off x="731520" y="91440"/>
+            <a:ext cx="8229600" cy="320040"/>
+          </a:xfrm>
+          <a:prstGeom prst="rect">
+            <a:avLst/>
+          </a:prstGeom>
+          <a:noFill/>
+        </p:spPr>
+        <p:txBody>
+          <a:bodyPr wrap="square" lIns="0" rIns="0" tIns="0" bIns="0" anchor="ctr">
+            <a:spAutoFit/>
+          </a:bodyPr>
+          <a:lstStyle/>
+          <a:p>
+            <a:pPr algn="l"/>
+            <a:r>
+              <a:rPr sz="1100" b="1">
+                <a:solidFill>
+                  <a:srgbClr val="B85C38"/>
+                </a:solidFill>
+                <a:latin typeface="Calibri"/>
+              </a:rPr>
+              <a:t>ANEXO TRAZABILIDAD · A.5</a:t>
+            </a:r>
+          </a:p>
+        </p:txBody>
+      </p:sp>
+      <p:sp>
+        <p:nvSpPr>
+          <p:cNvPr id="6" name="TextBox 5"/>
+          <p:cNvSpPr txBox="1"/>
+          <p:nvPr/>
+        </p:nvSpPr>
+        <p:spPr>
+          <a:xfrm>
+            <a:off x="10698480" y="91440"/>
+            <a:ext cx="1188720" cy="320040"/>
+          </a:xfrm>
+          <a:prstGeom prst="rect">
+            <a:avLst/>
+          </a:prstGeom>
+          <a:noFill/>
+        </p:spPr>
+        <p:txBody>
+          <a:bodyPr wrap="square" lIns="0" rIns="0" tIns="0" bIns="0" anchor="ctr">
+            <a:spAutoFit/>
+          </a:bodyPr>
+          <a:lstStyle/>
+          <a:p>
+            <a:pPr algn="r"/>
+            <a:r>
+              <a:rPr sz="900" b="0">
+                <a:solidFill>
+                  <a:srgbClr val="555555"/>
+                </a:solidFill>
+                <a:latin typeface="Calibri"/>
+              </a:rPr>
+              <a:t>Raíces Vivas · Entrega Final · CENFOTEC</a:t>
+            </a:r>
+          </a:p>
+        </p:txBody>
+      </p:sp>
+      <p:sp>
+        <p:nvSpPr>
+          <p:cNvPr id="7" name="TextBox 6"/>
+          <p:cNvSpPr txBox="1"/>
+          <p:nvPr/>
+        </p:nvSpPr>
+        <p:spPr>
+          <a:xfrm>
+            <a:off x="731520" y="640080"/>
+            <a:ext cx="10607040" cy="685800"/>
+          </a:xfrm>
+          <a:prstGeom prst="rect">
+            <a:avLst/>
+          </a:prstGeom>
+          <a:noFill/>
+        </p:spPr>
+        <p:txBody>
+          <a:bodyPr wrap="square" lIns="0" rIns="0" tIns="0" bIns="0" anchor="t">
+            <a:spAutoFit/>
+          </a:bodyPr>
+          <a:lstStyle/>
+          <a:p>
+            <a:pPr algn="l"/>
+            <a:r>
+              <a:rPr sz="3000" b="1">
+                <a:solidFill>
+                  <a:srgbClr val="133A32"/>
+                </a:solidFill>
+                <a:latin typeface="Calibri"/>
+              </a:rPr>
+              <a:t>QFD — Voz del usuario → requerimiento técnico</a:t>
+            </a:r>
+          </a:p>
+        </p:txBody>
+      </p:sp>
+      <p:sp>
+        <p:nvSpPr>
+          <p:cNvPr id="8" name="TextBox 7"/>
+          <p:cNvSpPr txBox="1"/>
+          <p:nvPr/>
+        </p:nvSpPr>
+        <p:spPr>
+          <a:xfrm>
+            <a:off x="731520" y="1325880"/>
+            <a:ext cx="10607040" cy="320040"/>
+          </a:xfrm>
+          <a:prstGeom prst="rect">
+            <a:avLst/>
+          </a:prstGeom>
+          <a:noFill/>
+        </p:spPr>
+        <p:txBody>
+          <a:bodyPr wrap="square" lIns="0" rIns="0" tIns="0" bIns="0" anchor="t">
+            <a:spAutoFit/>
+          </a:bodyPr>
+          <a:lstStyle/>
+          <a:p>
+            <a:pPr algn="l"/>
+            <a:r>
+              <a:rPr sz="1400" b="0">
+                <a:solidFill>
+                  <a:srgbClr val="4E6E66"/>
+                </a:solidFill>
+                <a:latin typeface="Calibri"/>
+              </a:rPr>
+              <a:t>Casa de la calidad del proyecto</a:t>
+            </a:r>
+          </a:p>
+        </p:txBody>
+      </p:sp>
+      <p:sp>
+        <p:nvSpPr>
+          <p:cNvPr id="9" name="Rectangle 8"/>
+          <p:cNvSpPr/>
+          <p:nvPr/>
+        </p:nvSpPr>
+        <p:spPr>
+          <a:xfrm>
+            <a:off x="685800" y="1828800"/>
+            <a:ext cx="10789920" cy="4023360"/>
+          </a:xfrm>
+          <a:prstGeom prst="rect">
+            <a:avLst/>
+          </a:prstGeom>
+          <a:solidFill>
+            <a:srgbClr val="FFFFFF"/>
+          </a:solidFill>
+          <a:ln w="9525">
+            <a:solidFill>
+              <a:srgbClr val="E9DEC9"/>
+            </a:solidFill>
+          </a:ln>
+          <a:effectLst/>
+        </p:spPr>
+        <p:style>
+          <a:lnRef idx="1">
+            <a:schemeClr val="accent1"/>
+          </a:lnRef>
+          <a:fillRef idx="3">
+            <a:schemeClr val="accent1"/>
+          </a:fillRef>
+          <a:effectRef idx="2">
+            <a:schemeClr val="accent1"/>
+          </a:effectRef>
+          <a:fontRef idx="minor">
+            <a:schemeClr val="lt1"/>
+          </a:fontRef>
+        </p:style>
+        <p:txBody>
+          <a:bodyPr rtlCol="0" anchor="ctr"/>
+          <a:lstStyle/>
+          <a:p>
+            <a:pPr algn="ctr"/>
+          </a:p>
+        </p:txBody>
+      </p:sp>
+      <p:pic>
+        <p:nvPicPr>
+          <p:cNvPr id="10" name="Picture 9" descr="diagram_qfd.png"/>
+          <p:cNvPicPr>
+            <a:picLocks noChangeAspect="1"/>
+          </p:cNvPicPr>
+          <p:nvPr/>
+        </p:nvPicPr>
+        <p:blipFill>
+          <a:blip r:embed="rId2"/>
+          <a:stretch>
+            <a:fillRect/>
+          </a:stretch>
+        </p:blipFill>
+        <p:spPr>
+          <a:xfrm>
+            <a:off x="3885015" y="1929384"/>
+            <a:ext cx="4391489" cy="3822191"/>
+          </a:xfrm>
+          <a:prstGeom prst="rect">
+            <a:avLst/>
+          </a:prstGeom>
+        </p:spPr>
+      </p:pic>
+      <p:sp>
+        <p:nvSpPr>
+          <p:cNvPr id="11" name="Rectangle 10"/>
+          <p:cNvSpPr/>
+          <p:nvPr/>
+        </p:nvSpPr>
+        <p:spPr>
+          <a:xfrm>
+            <a:off x="320040" y="5989320"/>
+            <a:ext cx="11871655" cy="685800"/>
+          </a:xfrm>
+          <a:prstGeom prst="rect">
+            <a:avLst/>
+          </a:prstGeom>
+          <a:solidFill>
+            <a:srgbClr val="133A32"/>
+          </a:solidFill>
+          <a:ln>
+            <a:noFill/>
+          </a:ln>
+          <a:effectLst/>
+        </p:spPr>
+        <p:style>
+          <a:lnRef idx="1">
+            <a:schemeClr val="accent1"/>
+          </a:lnRef>
+          <a:fillRef idx="3">
+            <a:schemeClr val="accent1"/>
+          </a:fillRef>
+          <a:effectRef idx="2">
+            <a:schemeClr val="accent1"/>
+          </a:effectRef>
+          <a:fontRef idx="minor">
+            <a:schemeClr val="lt1"/>
+          </a:fontRef>
+        </p:style>
+        <p:txBody>
+          <a:bodyPr rtlCol="0" anchor="ctr"/>
+          <a:lstStyle/>
+          <a:p>
+            <a:pPr algn="ctr"/>
+          </a:p>
+        </p:txBody>
+      </p:sp>
+      <p:sp>
+        <p:nvSpPr>
+          <p:cNvPr id="12" name="TextBox 11"/>
+          <p:cNvSpPr txBox="1"/>
+          <p:nvPr/>
+        </p:nvSpPr>
+        <p:spPr>
+          <a:xfrm>
+            <a:off x="731520" y="6035040"/>
+            <a:ext cx="10607040" cy="594360"/>
+          </a:xfrm>
+          <a:prstGeom prst="rect">
+            <a:avLst/>
+          </a:prstGeom>
+          <a:noFill/>
+        </p:spPr>
+        <p:txBody>
+          <a:bodyPr wrap="square" lIns="0" rIns="0" tIns="0" bIns="0" anchor="ctr">
+            <a:spAutoFit/>
+          </a:bodyPr>
+          <a:lstStyle/>
+          <a:p>
+            <a:pPr algn="l"/>
+            <a:r>
+              <a:rPr sz="1100" b="0">
+                <a:solidFill>
+                  <a:srgbClr val="F5EDE0"/>
+                </a:solidFill>
+                <a:latin typeface="Calibri"/>
+              </a:rPr>
+              <a:t>Priorización de requerimientos funcionales según el peso de cada necesidad levantada en campo. Fundamenta la clasificación MoSCoW (12 Must · 7 Should · 4 Could).</a:t>
+            </a:r>
+          </a:p>
+        </p:txBody>
+      </p:sp>
+      <p:pic>
+        <p:nvPicPr>
+          <p:cNvPr id="13" name="Picture 12" descr="logo-cenfotec-200x200.png"/>
+          <p:cNvPicPr>
+            <a:picLocks noChangeAspect="1"/>
+          </p:cNvPicPr>
+          <p:nvPr/>
+        </p:nvPicPr>
+        <p:blipFill>
+          <a:blip r:embed="rId3"/>
+          <a:stretch>
+            <a:fillRect/>
+          </a:stretch>
+        </p:blipFill>
+        <p:spPr>
+          <a:xfrm>
+            <a:off x="11430000" y="6172200"/>
+            <a:ext cx="411480" cy="411480"/>
+          </a:xfrm>
+          <a:prstGeom prst="rect">
+            <a:avLst/>
+          </a:prstGeom>
+        </p:spPr>
+      </p:pic>
+    </p:spTree>
+  </p:cSld>
+  <p:clrMapOvr>
+    <a:masterClrMapping/>
+  </p:clrMapOvr>
+</p:sld>
+</file>
+
 <file path=ppt/slides/slide2.xml><?xml version="1.0" encoding="utf-8"?>
 <p:sld xmlns:a="http://schemas.openxmlformats.org/drawingml/2006/main" xmlns:r="http://schemas.openxmlformats.org/officeDocument/2006/relationships" xmlns:p="http://schemas.openxmlformats.org/presentationml/2006/main">
   <p:cSld name="Slide 2">
@@ -14586,6 +16908,932 @@
           </a:p>
         </p:txBody>
       </p:sp>
+    </p:spTree>
+  </p:cSld>
+  <p:clrMapOvr>
+    <a:masterClrMapping/>
+  </p:clrMapOvr>
+</p:sld>
+</file>
+
+<file path=ppt/slides/slide20.xml><?xml version="1.0" encoding="utf-8"?>
+<p:sld xmlns:a="http://schemas.openxmlformats.org/drawingml/2006/main" xmlns:p="http://schemas.openxmlformats.org/presentationml/2006/main" xmlns:r="http://schemas.openxmlformats.org/officeDocument/2006/relationships">
+  <p:cSld>
+    <p:spTree>
+      <p:nvGrpSpPr>
+        <p:cNvPr id="1" name=""/>
+        <p:cNvGrpSpPr/>
+        <p:nvPr/>
+      </p:nvGrpSpPr>
+      <p:grpSpPr/>
+      <p:sp>
+        <p:nvSpPr>
+          <p:cNvPr id="2" name="Rectangle 1"/>
+          <p:cNvSpPr/>
+          <p:nvPr/>
+        </p:nvSpPr>
+        <p:spPr>
+          <a:xfrm>
+            <a:off x="0" y="0"/>
+            <a:ext cx="12191695" cy="6858000"/>
+          </a:xfrm>
+          <a:prstGeom prst="rect">
+            <a:avLst/>
+          </a:prstGeom>
+          <a:solidFill>
+            <a:srgbClr val="F5EDE0"/>
+          </a:solidFill>
+          <a:ln>
+            <a:noFill/>
+          </a:ln>
+          <a:effectLst/>
+        </p:spPr>
+        <p:style>
+          <a:lnRef idx="1">
+            <a:schemeClr val="accent1"/>
+          </a:lnRef>
+          <a:fillRef idx="3">
+            <a:schemeClr val="accent1"/>
+          </a:fillRef>
+          <a:effectRef idx="2">
+            <a:schemeClr val="accent1"/>
+          </a:effectRef>
+          <a:fontRef idx="minor">
+            <a:schemeClr val="lt1"/>
+          </a:fontRef>
+        </p:style>
+        <p:txBody>
+          <a:bodyPr rtlCol="0" anchor="ctr"/>
+          <a:lstStyle/>
+          <a:p>
+            <a:pPr algn="ctr"/>
+          </a:p>
+        </p:txBody>
+      </p:sp>
+      <p:sp>
+        <p:nvSpPr>
+          <p:cNvPr id="3" name="Rectangle 2"/>
+          <p:cNvSpPr/>
+          <p:nvPr/>
+        </p:nvSpPr>
+        <p:spPr>
+          <a:xfrm>
+            <a:off x="0" y="0"/>
+            <a:ext cx="320040" cy="6858000"/>
+          </a:xfrm>
+          <a:prstGeom prst="rect">
+            <a:avLst/>
+          </a:prstGeom>
+          <a:solidFill>
+            <a:srgbClr val="133A32"/>
+          </a:solidFill>
+          <a:ln>
+            <a:noFill/>
+          </a:ln>
+          <a:effectLst/>
+        </p:spPr>
+        <p:style>
+          <a:lnRef idx="1">
+            <a:schemeClr val="accent1"/>
+          </a:lnRef>
+          <a:fillRef idx="3">
+            <a:schemeClr val="accent1"/>
+          </a:fillRef>
+          <a:effectRef idx="2">
+            <a:schemeClr val="accent1"/>
+          </a:effectRef>
+          <a:fontRef idx="minor">
+            <a:schemeClr val="lt1"/>
+          </a:fontRef>
+        </p:style>
+        <p:txBody>
+          <a:bodyPr rtlCol="0" anchor="ctr"/>
+          <a:lstStyle/>
+          <a:p>
+            <a:pPr algn="ctr"/>
+          </a:p>
+        </p:txBody>
+      </p:sp>
+      <p:sp>
+        <p:nvSpPr>
+          <p:cNvPr id="4" name="Rectangle 3"/>
+          <p:cNvSpPr/>
+          <p:nvPr/>
+        </p:nvSpPr>
+        <p:spPr>
+          <a:xfrm>
+            <a:off x="320040" y="0"/>
+            <a:ext cx="11871655" cy="502920"/>
+          </a:xfrm>
+          <a:prstGeom prst="rect">
+            <a:avLst/>
+          </a:prstGeom>
+          <a:solidFill>
+            <a:srgbClr val="E9DEC9"/>
+          </a:solidFill>
+          <a:ln>
+            <a:noFill/>
+          </a:ln>
+          <a:effectLst/>
+        </p:spPr>
+        <p:style>
+          <a:lnRef idx="1">
+            <a:schemeClr val="accent1"/>
+          </a:lnRef>
+          <a:fillRef idx="3">
+            <a:schemeClr val="accent1"/>
+          </a:fillRef>
+          <a:effectRef idx="2">
+            <a:schemeClr val="accent1"/>
+          </a:effectRef>
+          <a:fontRef idx="minor">
+            <a:schemeClr val="lt1"/>
+          </a:fontRef>
+        </p:style>
+        <p:txBody>
+          <a:bodyPr rtlCol="0" anchor="ctr"/>
+          <a:lstStyle/>
+          <a:p>
+            <a:pPr algn="ctr"/>
+          </a:p>
+        </p:txBody>
+      </p:sp>
+      <p:sp>
+        <p:nvSpPr>
+          <p:cNvPr id="5" name="TextBox 4"/>
+          <p:cNvSpPr txBox="1"/>
+          <p:nvPr/>
+        </p:nvSpPr>
+        <p:spPr>
+          <a:xfrm>
+            <a:off x="731520" y="91440"/>
+            <a:ext cx="8229600" cy="320040"/>
+          </a:xfrm>
+          <a:prstGeom prst="rect">
+            <a:avLst/>
+          </a:prstGeom>
+          <a:noFill/>
+        </p:spPr>
+        <p:txBody>
+          <a:bodyPr wrap="square" lIns="0" rIns="0" tIns="0" bIns="0" anchor="ctr">
+            <a:spAutoFit/>
+          </a:bodyPr>
+          <a:lstStyle/>
+          <a:p>
+            <a:pPr algn="l"/>
+            <a:r>
+              <a:rPr sz="1100" b="1">
+                <a:solidFill>
+                  <a:srgbClr val="B85C38"/>
+                </a:solidFill>
+                <a:latin typeface="Calibri"/>
+              </a:rPr>
+              <a:t>ANEXO GESTIÓN · A.6</a:t>
+            </a:r>
+          </a:p>
+        </p:txBody>
+      </p:sp>
+      <p:sp>
+        <p:nvSpPr>
+          <p:cNvPr id="6" name="TextBox 5"/>
+          <p:cNvSpPr txBox="1"/>
+          <p:nvPr/>
+        </p:nvSpPr>
+        <p:spPr>
+          <a:xfrm>
+            <a:off x="10698480" y="91440"/>
+            <a:ext cx="1188720" cy="320040"/>
+          </a:xfrm>
+          <a:prstGeom prst="rect">
+            <a:avLst/>
+          </a:prstGeom>
+          <a:noFill/>
+        </p:spPr>
+        <p:txBody>
+          <a:bodyPr wrap="square" lIns="0" rIns="0" tIns="0" bIns="0" anchor="ctr">
+            <a:spAutoFit/>
+          </a:bodyPr>
+          <a:lstStyle/>
+          <a:p>
+            <a:pPr algn="r"/>
+            <a:r>
+              <a:rPr sz="900" b="0">
+                <a:solidFill>
+                  <a:srgbClr val="555555"/>
+                </a:solidFill>
+                <a:latin typeface="Calibri"/>
+              </a:rPr>
+              <a:t>Raíces Vivas · Entrega Final · CENFOTEC</a:t>
+            </a:r>
+          </a:p>
+        </p:txBody>
+      </p:sp>
+      <p:sp>
+        <p:nvSpPr>
+          <p:cNvPr id="7" name="TextBox 6"/>
+          <p:cNvSpPr txBox="1"/>
+          <p:nvPr/>
+        </p:nvSpPr>
+        <p:spPr>
+          <a:xfrm>
+            <a:off x="731520" y="640080"/>
+            <a:ext cx="10607040" cy="685800"/>
+          </a:xfrm>
+          <a:prstGeom prst="rect">
+            <a:avLst/>
+          </a:prstGeom>
+          <a:noFill/>
+        </p:spPr>
+        <p:txBody>
+          <a:bodyPr wrap="square" lIns="0" rIns="0" tIns="0" bIns="0" anchor="t">
+            <a:spAutoFit/>
+          </a:bodyPr>
+          <a:lstStyle/>
+          <a:p>
+            <a:pPr algn="l"/>
+            <a:r>
+              <a:rPr sz="3000" b="1">
+                <a:solidFill>
+                  <a:srgbClr val="133A32"/>
+                </a:solidFill>
+                <a:latin typeface="Calibri"/>
+              </a:rPr>
+              <a:t>Análisis FODA</a:t>
+            </a:r>
+          </a:p>
+        </p:txBody>
+      </p:sp>
+      <p:sp>
+        <p:nvSpPr>
+          <p:cNvPr id="8" name="TextBox 7"/>
+          <p:cNvSpPr txBox="1"/>
+          <p:nvPr/>
+        </p:nvSpPr>
+        <p:spPr>
+          <a:xfrm>
+            <a:off x="731520" y="1325880"/>
+            <a:ext cx="10607040" cy="320040"/>
+          </a:xfrm>
+          <a:prstGeom prst="rect">
+            <a:avLst/>
+          </a:prstGeom>
+          <a:noFill/>
+        </p:spPr>
+        <p:txBody>
+          <a:bodyPr wrap="square" lIns="0" rIns="0" tIns="0" bIns="0" anchor="t">
+            <a:spAutoFit/>
+          </a:bodyPr>
+          <a:lstStyle/>
+          <a:p>
+            <a:pPr algn="l"/>
+            <a:r>
+              <a:rPr sz="1400" b="0">
+                <a:solidFill>
+                  <a:srgbClr val="4E6E66"/>
+                </a:solidFill>
+                <a:latin typeface="Calibri"/>
+              </a:rPr>
+              <a:t>Fortalezas · Oportunidades · Debilidades · Amenazas</a:t>
+            </a:r>
+          </a:p>
+        </p:txBody>
+      </p:sp>
+      <p:sp>
+        <p:nvSpPr>
+          <p:cNvPr id="9" name="Rectangle 8"/>
+          <p:cNvSpPr/>
+          <p:nvPr/>
+        </p:nvSpPr>
+        <p:spPr>
+          <a:xfrm>
+            <a:off x="685800" y="1828800"/>
+            <a:ext cx="10789920" cy="4023360"/>
+          </a:xfrm>
+          <a:prstGeom prst="rect">
+            <a:avLst/>
+          </a:prstGeom>
+          <a:solidFill>
+            <a:srgbClr val="FFFFFF"/>
+          </a:solidFill>
+          <a:ln w="9525">
+            <a:solidFill>
+              <a:srgbClr val="E9DEC9"/>
+            </a:solidFill>
+          </a:ln>
+          <a:effectLst/>
+        </p:spPr>
+        <p:style>
+          <a:lnRef idx="1">
+            <a:schemeClr val="accent1"/>
+          </a:lnRef>
+          <a:fillRef idx="3">
+            <a:schemeClr val="accent1"/>
+          </a:fillRef>
+          <a:effectRef idx="2">
+            <a:schemeClr val="accent1"/>
+          </a:effectRef>
+          <a:fontRef idx="minor">
+            <a:schemeClr val="lt1"/>
+          </a:fontRef>
+        </p:style>
+        <p:txBody>
+          <a:bodyPr rtlCol="0" anchor="ctr"/>
+          <a:lstStyle/>
+          <a:p>
+            <a:pPr algn="ctr"/>
+          </a:p>
+        </p:txBody>
+      </p:sp>
+      <p:pic>
+        <p:nvPicPr>
+          <p:cNvPr id="10" name="Picture 9" descr="diagram_foda.png"/>
+          <p:cNvPicPr>
+            <a:picLocks noChangeAspect="1"/>
+          </p:cNvPicPr>
+          <p:nvPr/>
+        </p:nvPicPr>
+        <p:blipFill>
+          <a:blip r:embed="rId2"/>
+          <a:stretch>
+            <a:fillRect/>
+          </a:stretch>
+        </p:blipFill>
+        <p:spPr>
+          <a:xfrm>
+            <a:off x="3912233" y="1929384"/>
+            <a:ext cx="4337053" cy="3822191"/>
+          </a:xfrm>
+          <a:prstGeom prst="rect">
+            <a:avLst/>
+          </a:prstGeom>
+        </p:spPr>
+      </p:pic>
+      <p:sp>
+        <p:nvSpPr>
+          <p:cNvPr id="11" name="Rectangle 10"/>
+          <p:cNvSpPr/>
+          <p:nvPr/>
+        </p:nvSpPr>
+        <p:spPr>
+          <a:xfrm>
+            <a:off x="320040" y="5989320"/>
+            <a:ext cx="11871655" cy="685800"/>
+          </a:xfrm>
+          <a:prstGeom prst="rect">
+            <a:avLst/>
+          </a:prstGeom>
+          <a:solidFill>
+            <a:srgbClr val="133A32"/>
+          </a:solidFill>
+          <a:ln>
+            <a:noFill/>
+          </a:ln>
+          <a:effectLst/>
+        </p:spPr>
+        <p:style>
+          <a:lnRef idx="1">
+            <a:schemeClr val="accent1"/>
+          </a:lnRef>
+          <a:fillRef idx="3">
+            <a:schemeClr val="accent1"/>
+          </a:fillRef>
+          <a:effectRef idx="2">
+            <a:schemeClr val="accent1"/>
+          </a:effectRef>
+          <a:fontRef idx="minor">
+            <a:schemeClr val="lt1"/>
+          </a:fontRef>
+        </p:style>
+        <p:txBody>
+          <a:bodyPr rtlCol="0" anchor="ctr"/>
+          <a:lstStyle/>
+          <a:p>
+            <a:pPr algn="ctr"/>
+          </a:p>
+        </p:txBody>
+      </p:sp>
+      <p:sp>
+        <p:nvSpPr>
+          <p:cNvPr id="12" name="TextBox 11"/>
+          <p:cNvSpPr txBox="1"/>
+          <p:nvPr/>
+        </p:nvSpPr>
+        <p:spPr>
+          <a:xfrm>
+            <a:off x="731520" y="6035040"/>
+            <a:ext cx="10607040" cy="594360"/>
+          </a:xfrm>
+          <a:prstGeom prst="rect">
+            <a:avLst/>
+          </a:prstGeom>
+          <a:noFill/>
+        </p:spPr>
+        <p:txBody>
+          <a:bodyPr wrap="square" lIns="0" rIns="0" tIns="0" bIns="0" anchor="ctr">
+            <a:spAutoFit/>
+          </a:bodyPr>
+          <a:lstStyle/>
+          <a:p>
+            <a:pPr algn="l"/>
+            <a:r>
+              <a:rPr sz="1100" b="0">
+                <a:solidFill>
+                  <a:srgbClr val="F5EDE0"/>
+                </a:solidFill>
+                <a:latin typeface="Calibri"/>
+              </a:rPr>
+              <a:t>Diagnóstico estratégico del proyecto en el contexto académico, territorial y técnico. Alimenta el registro de riesgos y el roadmap de continuidad.</a:t>
+            </a:r>
+          </a:p>
+        </p:txBody>
+      </p:sp>
+      <p:pic>
+        <p:nvPicPr>
+          <p:cNvPr id="13" name="Picture 12" descr="logo-cenfotec-200x200.png"/>
+          <p:cNvPicPr>
+            <a:picLocks noChangeAspect="1"/>
+          </p:cNvPicPr>
+          <p:nvPr/>
+        </p:nvPicPr>
+        <p:blipFill>
+          <a:blip r:embed="rId3"/>
+          <a:stretch>
+            <a:fillRect/>
+          </a:stretch>
+        </p:blipFill>
+        <p:spPr>
+          <a:xfrm>
+            <a:off x="11430000" y="6172200"/>
+            <a:ext cx="411480" cy="411480"/>
+          </a:xfrm>
+          <a:prstGeom prst="rect">
+            <a:avLst/>
+          </a:prstGeom>
+        </p:spPr>
+      </p:pic>
+    </p:spTree>
+  </p:cSld>
+  <p:clrMapOvr>
+    <a:masterClrMapping/>
+  </p:clrMapOvr>
+</p:sld>
+</file>
+
+<file path=ppt/slides/slide21.xml><?xml version="1.0" encoding="utf-8"?>
+<p:sld xmlns:a="http://schemas.openxmlformats.org/drawingml/2006/main" xmlns:p="http://schemas.openxmlformats.org/presentationml/2006/main" xmlns:r="http://schemas.openxmlformats.org/officeDocument/2006/relationships">
+  <p:cSld>
+    <p:spTree>
+      <p:nvGrpSpPr>
+        <p:cNvPr id="1" name=""/>
+        <p:cNvGrpSpPr/>
+        <p:nvPr/>
+      </p:nvGrpSpPr>
+      <p:grpSpPr/>
+      <p:sp>
+        <p:nvSpPr>
+          <p:cNvPr id="2" name="Rectangle 1"/>
+          <p:cNvSpPr/>
+          <p:nvPr/>
+        </p:nvSpPr>
+        <p:spPr>
+          <a:xfrm>
+            <a:off x="0" y="0"/>
+            <a:ext cx="12191695" cy="6858000"/>
+          </a:xfrm>
+          <a:prstGeom prst="rect">
+            <a:avLst/>
+          </a:prstGeom>
+          <a:solidFill>
+            <a:srgbClr val="F5EDE0"/>
+          </a:solidFill>
+          <a:ln>
+            <a:noFill/>
+          </a:ln>
+          <a:effectLst/>
+        </p:spPr>
+        <p:style>
+          <a:lnRef idx="1">
+            <a:schemeClr val="accent1"/>
+          </a:lnRef>
+          <a:fillRef idx="3">
+            <a:schemeClr val="accent1"/>
+          </a:fillRef>
+          <a:effectRef idx="2">
+            <a:schemeClr val="accent1"/>
+          </a:effectRef>
+          <a:fontRef idx="minor">
+            <a:schemeClr val="lt1"/>
+          </a:fontRef>
+        </p:style>
+        <p:txBody>
+          <a:bodyPr rtlCol="0" anchor="ctr"/>
+          <a:lstStyle/>
+          <a:p>
+            <a:pPr algn="ctr"/>
+          </a:p>
+        </p:txBody>
+      </p:sp>
+      <p:sp>
+        <p:nvSpPr>
+          <p:cNvPr id="3" name="Rectangle 2"/>
+          <p:cNvSpPr/>
+          <p:nvPr/>
+        </p:nvSpPr>
+        <p:spPr>
+          <a:xfrm>
+            <a:off x="0" y="0"/>
+            <a:ext cx="320040" cy="6858000"/>
+          </a:xfrm>
+          <a:prstGeom prst="rect">
+            <a:avLst/>
+          </a:prstGeom>
+          <a:solidFill>
+            <a:srgbClr val="133A32"/>
+          </a:solidFill>
+          <a:ln>
+            <a:noFill/>
+          </a:ln>
+          <a:effectLst/>
+        </p:spPr>
+        <p:style>
+          <a:lnRef idx="1">
+            <a:schemeClr val="accent1"/>
+          </a:lnRef>
+          <a:fillRef idx="3">
+            <a:schemeClr val="accent1"/>
+          </a:fillRef>
+          <a:effectRef idx="2">
+            <a:schemeClr val="accent1"/>
+          </a:effectRef>
+          <a:fontRef idx="minor">
+            <a:schemeClr val="lt1"/>
+          </a:fontRef>
+        </p:style>
+        <p:txBody>
+          <a:bodyPr rtlCol="0" anchor="ctr"/>
+          <a:lstStyle/>
+          <a:p>
+            <a:pPr algn="ctr"/>
+          </a:p>
+        </p:txBody>
+      </p:sp>
+      <p:sp>
+        <p:nvSpPr>
+          <p:cNvPr id="4" name="Rectangle 3"/>
+          <p:cNvSpPr/>
+          <p:nvPr/>
+        </p:nvSpPr>
+        <p:spPr>
+          <a:xfrm>
+            <a:off x="320040" y="0"/>
+            <a:ext cx="11871655" cy="502920"/>
+          </a:xfrm>
+          <a:prstGeom prst="rect">
+            <a:avLst/>
+          </a:prstGeom>
+          <a:solidFill>
+            <a:srgbClr val="E9DEC9"/>
+          </a:solidFill>
+          <a:ln>
+            <a:noFill/>
+          </a:ln>
+          <a:effectLst/>
+        </p:spPr>
+        <p:style>
+          <a:lnRef idx="1">
+            <a:schemeClr val="accent1"/>
+          </a:lnRef>
+          <a:fillRef idx="3">
+            <a:schemeClr val="accent1"/>
+          </a:fillRef>
+          <a:effectRef idx="2">
+            <a:schemeClr val="accent1"/>
+          </a:effectRef>
+          <a:fontRef idx="minor">
+            <a:schemeClr val="lt1"/>
+          </a:fontRef>
+        </p:style>
+        <p:txBody>
+          <a:bodyPr rtlCol="0" anchor="ctr"/>
+          <a:lstStyle/>
+          <a:p>
+            <a:pPr algn="ctr"/>
+          </a:p>
+        </p:txBody>
+      </p:sp>
+      <p:sp>
+        <p:nvSpPr>
+          <p:cNvPr id="5" name="TextBox 4"/>
+          <p:cNvSpPr txBox="1"/>
+          <p:nvPr/>
+        </p:nvSpPr>
+        <p:spPr>
+          <a:xfrm>
+            <a:off x="731520" y="91440"/>
+            <a:ext cx="8229600" cy="320040"/>
+          </a:xfrm>
+          <a:prstGeom prst="rect">
+            <a:avLst/>
+          </a:prstGeom>
+          <a:noFill/>
+        </p:spPr>
+        <p:txBody>
+          <a:bodyPr wrap="square" lIns="0" rIns="0" tIns="0" bIns="0" anchor="ctr">
+            <a:spAutoFit/>
+          </a:bodyPr>
+          <a:lstStyle/>
+          <a:p>
+            <a:pPr algn="l"/>
+            <a:r>
+              <a:rPr sz="1100" b="1">
+                <a:solidFill>
+                  <a:srgbClr val="B85C38"/>
+                </a:solidFill>
+                <a:latin typeface="Calibri"/>
+              </a:rPr>
+              <a:t>ANEXO GESTIÓN · A.7</a:t>
+            </a:r>
+          </a:p>
+        </p:txBody>
+      </p:sp>
+      <p:sp>
+        <p:nvSpPr>
+          <p:cNvPr id="6" name="TextBox 5"/>
+          <p:cNvSpPr txBox="1"/>
+          <p:nvPr/>
+        </p:nvSpPr>
+        <p:spPr>
+          <a:xfrm>
+            <a:off x="10698480" y="91440"/>
+            <a:ext cx="1188720" cy="320040"/>
+          </a:xfrm>
+          <a:prstGeom prst="rect">
+            <a:avLst/>
+          </a:prstGeom>
+          <a:noFill/>
+        </p:spPr>
+        <p:txBody>
+          <a:bodyPr wrap="square" lIns="0" rIns="0" tIns="0" bIns="0" anchor="ctr">
+            <a:spAutoFit/>
+          </a:bodyPr>
+          <a:lstStyle/>
+          <a:p>
+            <a:pPr algn="r"/>
+            <a:r>
+              <a:rPr sz="900" b="0">
+                <a:solidFill>
+                  <a:srgbClr val="555555"/>
+                </a:solidFill>
+                <a:latin typeface="Calibri"/>
+              </a:rPr>
+              <a:t>Raíces Vivas · Entrega Final · CENFOTEC</a:t>
+            </a:r>
+          </a:p>
+        </p:txBody>
+      </p:sp>
+      <p:sp>
+        <p:nvSpPr>
+          <p:cNvPr id="7" name="TextBox 6"/>
+          <p:cNvSpPr txBox="1"/>
+          <p:nvPr/>
+        </p:nvSpPr>
+        <p:spPr>
+          <a:xfrm>
+            <a:off x="731520" y="640080"/>
+            <a:ext cx="10607040" cy="685800"/>
+          </a:xfrm>
+          <a:prstGeom prst="rect">
+            <a:avLst/>
+          </a:prstGeom>
+          <a:noFill/>
+        </p:spPr>
+        <p:txBody>
+          <a:bodyPr wrap="square" lIns="0" rIns="0" tIns="0" bIns="0" anchor="t">
+            <a:spAutoFit/>
+          </a:bodyPr>
+          <a:lstStyle/>
+          <a:p>
+            <a:pPr algn="l"/>
+            <a:r>
+              <a:rPr sz="3000" b="1">
+                <a:solidFill>
+                  <a:srgbClr val="133A32"/>
+                </a:solidFill>
+                <a:latin typeface="Calibri"/>
+              </a:rPr>
+              <a:t>Análisis de causa-raíz — Ishikawa</a:t>
+            </a:r>
+          </a:p>
+        </p:txBody>
+      </p:sp>
+      <p:sp>
+        <p:nvSpPr>
+          <p:cNvPr id="8" name="TextBox 7"/>
+          <p:cNvSpPr txBox="1"/>
+          <p:nvPr/>
+        </p:nvSpPr>
+        <p:spPr>
+          <a:xfrm>
+            <a:off x="731520" y="1325880"/>
+            <a:ext cx="10607040" cy="320040"/>
+          </a:xfrm>
+          <a:prstGeom prst="rect">
+            <a:avLst/>
+          </a:prstGeom>
+          <a:noFill/>
+        </p:spPr>
+        <p:txBody>
+          <a:bodyPr wrap="square" lIns="0" rIns="0" tIns="0" bIns="0" anchor="t">
+            <a:spAutoFit/>
+          </a:bodyPr>
+          <a:lstStyle/>
+          <a:p>
+            <a:pPr algn="l"/>
+            <a:r>
+              <a:rPr sz="1400" b="0">
+                <a:solidFill>
+                  <a:srgbClr val="4E6E66"/>
+                </a:solidFill>
+                <a:latin typeface="Calibri"/>
+              </a:rPr>
+              <a:t>6M · por qué persiste la brecha sociotécnica</a:t>
+            </a:r>
+          </a:p>
+        </p:txBody>
+      </p:sp>
+      <p:sp>
+        <p:nvSpPr>
+          <p:cNvPr id="9" name="Rectangle 8"/>
+          <p:cNvSpPr/>
+          <p:nvPr/>
+        </p:nvSpPr>
+        <p:spPr>
+          <a:xfrm>
+            <a:off x="685800" y="1828800"/>
+            <a:ext cx="10789920" cy="4023360"/>
+          </a:xfrm>
+          <a:prstGeom prst="rect">
+            <a:avLst/>
+          </a:prstGeom>
+          <a:solidFill>
+            <a:srgbClr val="FFFFFF"/>
+          </a:solidFill>
+          <a:ln w="9525">
+            <a:solidFill>
+              <a:srgbClr val="E9DEC9"/>
+            </a:solidFill>
+          </a:ln>
+          <a:effectLst/>
+        </p:spPr>
+        <p:style>
+          <a:lnRef idx="1">
+            <a:schemeClr val="accent1"/>
+          </a:lnRef>
+          <a:fillRef idx="3">
+            <a:schemeClr val="accent1"/>
+          </a:fillRef>
+          <a:effectRef idx="2">
+            <a:schemeClr val="accent1"/>
+          </a:effectRef>
+          <a:fontRef idx="minor">
+            <a:schemeClr val="lt1"/>
+          </a:fontRef>
+        </p:style>
+        <p:txBody>
+          <a:bodyPr rtlCol="0" anchor="ctr"/>
+          <a:lstStyle/>
+          <a:p>
+            <a:pPr algn="ctr"/>
+          </a:p>
+        </p:txBody>
+      </p:sp>
+      <p:pic>
+        <p:nvPicPr>
+          <p:cNvPr id="10" name="Picture 9" descr="diagram_ishikawa.png"/>
+          <p:cNvPicPr>
+            <a:picLocks noChangeAspect="1"/>
+          </p:cNvPicPr>
+          <p:nvPr/>
+        </p:nvPicPr>
+        <p:blipFill>
+          <a:blip r:embed="rId2"/>
+          <a:stretch>
+            <a:fillRect/>
+          </a:stretch>
+        </p:blipFill>
+        <p:spPr>
+          <a:xfrm>
+            <a:off x="3300884" y="1929384"/>
+            <a:ext cx="5559750" cy="3822191"/>
+          </a:xfrm>
+          <a:prstGeom prst="rect">
+            <a:avLst/>
+          </a:prstGeom>
+        </p:spPr>
+      </p:pic>
+      <p:sp>
+        <p:nvSpPr>
+          <p:cNvPr id="11" name="Rectangle 10"/>
+          <p:cNvSpPr/>
+          <p:nvPr/>
+        </p:nvSpPr>
+        <p:spPr>
+          <a:xfrm>
+            <a:off x="320040" y="5989320"/>
+            <a:ext cx="11871655" cy="685800"/>
+          </a:xfrm>
+          <a:prstGeom prst="rect">
+            <a:avLst/>
+          </a:prstGeom>
+          <a:solidFill>
+            <a:srgbClr val="133A32"/>
+          </a:solidFill>
+          <a:ln>
+            <a:noFill/>
+          </a:ln>
+          <a:effectLst/>
+        </p:spPr>
+        <p:style>
+          <a:lnRef idx="1">
+            <a:schemeClr val="accent1"/>
+          </a:lnRef>
+          <a:fillRef idx="3">
+            <a:schemeClr val="accent1"/>
+          </a:fillRef>
+          <a:effectRef idx="2">
+            <a:schemeClr val="accent1"/>
+          </a:effectRef>
+          <a:fontRef idx="minor">
+            <a:schemeClr val="lt1"/>
+          </a:fontRef>
+        </p:style>
+        <p:txBody>
+          <a:bodyPr rtlCol="0" anchor="ctr"/>
+          <a:lstStyle/>
+          <a:p>
+            <a:pPr algn="ctr"/>
+          </a:p>
+        </p:txBody>
+      </p:sp>
+      <p:sp>
+        <p:nvSpPr>
+          <p:cNvPr id="12" name="TextBox 11"/>
+          <p:cNvSpPr txBox="1"/>
+          <p:nvPr/>
+        </p:nvSpPr>
+        <p:spPr>
+          <a:xfrm>
+            <a:off x="731520" y="6035040"/>
+            <a:ext cx="10607040" cy="594360"/>
+          </a:xfrm>
+          <a:prstGeom prst="rect">
+            <a:avLst/>
+          </a:prstGeom>
+          <a:noFill/>
+        </p:spPr>
+        <p:txBody>
+          <a:bodyPr wrap="square" lIns="0" rIns="0" tIns="0" bIns="0" anchor="ctr">
+            <a:spAutoFit/>
+          </a:bodyPr>
+          <a:lstStyle/>
+          <a:p>
+            <a:pPr algn="l"/>
+            <a:r>
+              <a:rPr sz="1100" b="0">
+                <a:solidFill>
+                  <a:srgbClr val="F5EDE0"/>
+                </a:solidFill>
+                <a:latin typeface="Calibri"/>
+              </a:rPr>
+              <a:t>Espina de pescado que identifica causas estructurales (método, personas, materiales, entorno, tecnología y medición) detrás de la brecha en educación, saberes y salud comunitaria.</a:t>
+            </a:r>
+          </a:p>
+        </p:txBody>
+      </p:sp>
+      <p:pic>
+        <p:nvPicPr>
+          <p:cNvPr id="13" name="Picture 12" descr="logo-cenfotec-200x200.png"/>
+          <p:cNvPicPr>
+            <a:picLocks noChangeAspect="1"/>
+          </p:cNvPicPr>
+          <p:nvPr/>
+        </p:nvPicPr>
+        <p:blipFill>
+          <a:blip r:embed="rId3"/>
+          <a:stretch>
+            <a:fillRect/>
+          </a:stretch>
+        </p:blipFill>
+        <p:spPr>
+          <a:xfrm>
+            <a:off x="11430000" y="6172200"/>
+            <a:ext cx="411480" cy="411480"/>
+          </a:xfrm>
+          <a:prstGeom prst="rect">
+            <a:avLst/>
+          </a:prstGeom>
+        </p:spPr>
+      </p:pic>
     </p:spTree>
   </p:cSld>
   <p:clrMapOvr>

</xml_diff>